<commit_message>
Add scripts for building 3D models of the virtual patient and organs
- Introduced `build_body_model.py` to create a 3D virtual patient body from MakeHuman base mesh, including skin surface and morph targets.
- Added `build_organ_models.py` to generate anatomical 3D organ models from BodyParts3D, ensuring accurate scaling and positioning relative to the virtual patient.
- Created `render.yaml` for deploying the dashboard and API using Docker on Render.
</commit_message>
<xml_diff>
--- a/docs/presentation.pptx
+++ b/docs/presentation.pptx
@@ -29,9 +29,10 @@
     <p:sldId id="277" r:id="rId23"/>
     <p:sldId id="278" r:id="rId24"/>
     <p:sldId id="279" r:id="rId25"/>
+    <p:sldId id="280" r:id="rId26"/>
   </p:sldIdLst>
   <p:notesMasterIdLst>
-    <p:notesMasterId r:id="rId26"/>
+    <p:notesMasterId r:id="rId27"/>
   </p:notesMasterIdLst>
   <p:sldSz cx="12192000" cy="6858000"/>
   <p:notesSz cx="6858000" cy="12192000"/>
@@ -130,32 +131,32 @@
   <p:extLst>
     <p:ext uri="{521415D9-36F7-43E2-AB2F-B90AF26B5E84}">
       <p14:sectionLst xmlns:p14="http://schemas.microsoft.com/office/powerpoint/2010/main">
-        <p14:section name="Opening" id="{75b12e87-2a83-45b0-91a8-558111db176d}">
+        <p14:section name="Opening" id="{2e8e468d-06d9-33d7-dca3-a7ed1cac914b}">
           <p14:sldIdLst>
             <p14:sldId id="256"/>
             <p14:sldId id="257"/>
           </p14:sldIdLst>
         </p14:section>
-        <p14:section name="The digital twin" id="{44bb43d0-ba5c-c91c-b12b-3c72726e76fe}">
+        <p14:section name="The digital twin" id="{686723de-786e-3d71-e857-bcea11340dcb}">
           <p14:sldIdLst>
             <p14:sldId id="258"/>
             <p14:sldId id="259"/>
           </p14:sldIdLst>
         </p14:section>
-        <p14:section name="Data" id="{ae8b58f3-a060-8f80-811a-ee6cafd8f6ca}">
+        <p14:section name="Data" id="{4a501251-4526-85db-3933-59d8d6d1671d}">
           <p14:sldIdLst>
             <p14:sldId id="260"/>
             <p14:sldId id="261"/>
           </p14:sldIdLst>
         </p14:section>
-        <p14:section name="Model · Sync · Simulate" id="{0ab89962-bc72-84e6-b975-5cfa70e8f89a}">
+        <p14:section name="Model · Sync · Simulate" id="{a8815f1c-17bf-722e-4e17-0067cbd7e97f}">
           <p14:sldIdLst>
             <p14:sldId id="262"/>
             <p14:sldId id="263"/>
             <p14:sldId id="264"/>
           </p14:sldIdLst>
         </p14:section>
-        <p14:section name="Results" id="{6a7c32d2-1d5b-2738-468b-15c0c1734103}">
+        <p14:section name="Results" id="{6fa930e6-0da7-2f47-4d23-861957247f91}">
           <p14:sldIdLst>
             <p14:sldId id="265"/>
             <p14:sldId id="266"/>
@@ -167,19 +168,20 @@
             <p14:sldId id="272"/>
           </p14:sldIdLst>
         </p14:section>
-        <p14:section name="Dashboard" id="{bd6d2444-6314-339f-0171-50842d1f4f34}">
+        <p14:section name="Dashboard" id="{c23e3608-f6fb-868c-2acb-5a4c06e4caed}">
           <p14:sldIdLst>
             <p14:sldId id="273"/>
             <p14:sldId id="274"/>
             <p14:sldId id="275"/>
             <p14:sldId id="276"/>
+            <p14:sldId id="277"/>
           </p14:sldIdLst>
         </p14:section>
-        <p14:section name="Responsible by design" id="{7f17d586-cd9a-9ab3-90a0-b1f031c02e24}">
+        <p14:section name="Responsible by design" id="{1c197fd3-c935-0df9-df03-0c2a17a6a9e0}">
           <p14:sldIdLst>
-            <p14:sldId id="277"/>
             <p14:sldId id="278"/>
             <p14:sldId id="279"/>
+            <p14:sldId id="280"/>
           </p14:sldIdLst>
         </p14:section>
       </p14:sectionLst>
@@ -1642,7 +1644,7 @@
           <a:p>
             <a:r>
               <a:rPr lang="en-US" dirty="0"/>
-              <a:t>The doctor tests a meal swap or a walk on this patient's twin and sees the predicted peak change. Personal meal ranking shows which Indian meals suit this body. The patient companion delivers simple nudges in Hindi, Kannada or English.</a:t>
+              <a:t>The virtual patient is a real 3D human body, shaped from this patient's sex and BMI, with anatomical organs inside, each coloured by what the twin has learned about it. The heart beats at the patient's own night heart rate. Organ meshes: BodyParts3D, (c) 2008 Life Science Integrated Database Center, CC BY-SA 2.1 Japan.</a:t>
             </a:r>
             <a:endParaRPr lang="en-US" dirty="0"/>
           </a:p>
@@ -1730,7 +1732,7 @@
           <a:p>
             <a:r>
               <a:rPr lang="en-US" dirty="0"/>
-              <a:t>The therapy simulator replays yesterday's meals and activity for tomorrow, on this patient's synced twin, under the usual and an adjusted regimen: insulin and sulfonylurea doses and timing, DPP-4 and SGLT2 inhibitors, with stress tests such as a skipped lunch and a dose-response table. A trust check shows how well the twin reproduced the last 24 hours, and warns when it cannot be trusted.</a:t>
+              <a:t>The doctor tests a meal swap or a walk on this patient's twin and sees the predicted peak change. Personal meal ranking shows which Indian meals suit this body. The patient companion delivers simple nudges in Hindi, Kannada or English.</a:t>
             </a:r>
             <a:endParaRPr lang="en-US" dirty="0"/>
           </a:p>
@@ -1818,7 +1820,7 @@
           <a:p>
             <a:r>
               <a:rPr lang="en-US" dirty="0"/>
-              <a:t>Health data is the most sensitive personal data. The design follows the DPDP Act and ABDM, every answer is explainable, and the evaluation states its limits plainly.</a:t>
+              <a:t>The therapy simulator replays yesterday's meals and activity for tomorrow, on this patient's synced twin, under the usual and an adjusted regimen: insulin and sulfonylurea doses and timing, DPP-4 and SGLT2 inhibitors, with stress tests such as a skipped lunch and a dose-response table. A trust check shows how well the twin reproduced the last 24 hours, and warns when it cannot be trusted.</a:t>
             </a:r>
             <a:endParaRPr lang="en-US" dirty="0"/>
           </a:p>
@@ -1906,7 +1908,7 @@
           <a:p>
             <a:r>
               <a:rPr lang="en-US" dirty="0"/>
-              <a:t>Close with the path forward: clinical co-design, a pilot in Bengaluru, then prospective validation. The goal is measurable: fewer lows, more time in range, earlier action.</a:t>
+              <a:t>Health data is the most sensitive personal data. The design follows the DPDP Act and ABDM, every answer is explainable, and the evaluation states its limits plainly.</a:t>
             </a:r>
             <a:endParaRPr lang="en-US" dirty="0"/>
           </a:p>
@@ -1994,7 +1996,7 @@
           <a:p>
             <a:r>
               <a:rPr lang="en-US" dirty="0"/>
-              <a:t>Thank the jury and invite questions.</a:t>
+              <a:t>Close with the path forward: clinical co-design, a pilot in Bengaluru, then prospective validation. The goal is measurable: fewer lows, more time in range, earlier action.</a:t>
             </a:r>
             <a:endParaRPr lang="en-US" dirty="0"/>
           </a:p>
@@ -2018,6 +2020,94 @@
             <a:fld id="{F7021451-1387-4CA6-816F-3879F97B5CBC}" type="slidenum">
               <a:rPr lang="en-US"/>
               <a:t>24</a:t>
+            </a:fld>
+            <a:endParaRPr lang="en-US"/>
+          </a:p>
+        </p:txBody>
+      </p:sp>
+    </p:spTree>
+    <p:extLst>
+      <p:ext uri="{BB962C8B-B14F-4D97-AF65-F5344CB8AC3E}">
+        <p14:creationId xmlns:p14="http://schemas.microsoft.com/office/powerpoint/2010/main" val="1024086991"/>
+      </p:ext>
+    </p:extLst>
+  </p:cSld>
+  <p:clrMapOvr>
+    <a:masterClrMapping/>
+  </p:clrMapOvr>
+</p:notes>
+</file>
+
+<file path=ppt/notesSlides/notesSlide25.xml><?xml version="1.0" encoding="utf-8"?>
+<p:notes xmlns:a="http://schemas.openxmlformats.org/drawingml/2006/main" xmlns:r="http://schemas.openxmlformats.org/officeDocument/2006/relationships" xmlns:p="http://schemas.openxmlformats.org/presentationml/2006/main">
+  <p:cSld>
+    <p:spTree>
+      <p:nvGrpSpPr>
+        <p:cNvPr id="1" name=""/>
+        <p:cNvGrpSpPr/>
+        <p:nvPr/>
+      </p:nvGrpSpPr>
+      <p:grpSpPr>
+        <a:xfrm>
+          <a:off x="0" y="0"/>
+          <a:ext cx="0" cy="0"/>
+          <a:chOff x="0" y="0"/>
+          <a:chExt cx="0" cy="0"/>
+        </a:xfrm>
+      </p:grpSpPr>
+      <p:sp>
+        <p:nvSpPr>
+          <p:cNvPr id="2" name="Slide Image Placeholder 1"/>
+          <p:cNvSpPr>
+            <a:spLocks noGrp="1" noRot="1" noChangeAspect="1"/>
+          </p:cNvSpPr>
+          <p:nvPr>
+            <p:ph type="sldImg"/>
+          </p:nvPr>
+        </p:nvSpPr>
+        <p:spPr/>
+      </p:sp>
+      <p:sp>
+        <p:nvSpPr>
+          <p:cNvPr id="3" name="Notes Placeholder 2"/>
+          <p:cNvSpPr>
+            <a:spLocks noGrp="1"/>
+          </p:cNvSpPr>
+          <p:nvPr>
+            <p:ph type="body" idx="1"/>
+          </p:nvPr>
+        </p:nvSpPr>
+        <p:spPr/>
+        <p:txBody>
+          <a:bodyPr/>
+          <a:lstStyle/>
+          <a:p>
+            <a:r>
+              <a:rPr lang="en-US" dirty="0"/>
+              <a:t>Thank the jury and invite questions.</a:t>
+            </a:r>
+            <a:endParaRPr lang="en-US" dirty="0"/>
+          </a:p>
+        </p:txBody>
+      </p:sp>
+      <p:sp>
+        <p:nvSpPr>
+          <p:cNvPr id="4" name="Slide Number Placeholder 3"/>
+          <p:cNvSpPr>
+            <a:spLocks noGrp="1"/>
+          </p:cNvSpPr>
+          <p:nvPr>
+            <p:ph type="sldNum" sz="quarter" idx="10"/>
+          </p:nvPr>
+        </p:nvSpPr>
+        <p:spPr/>
+        <p:txBody>
+          <a:bodyPr/>
+          <a:lstStyle/>
+          <a:p>
+            <a:fld id="{F7021451-1387-4CA6-816F-3879F97B5CBC}" type="slidenum">
+              <a:rPr lang="en-US"/>
+              <a:t>25</a:t>
             </a:fld>
             <a:endParaRPr lang="en-US"/>
           </a:p>
@@ -10370,15 +10460,51 @@
                 <a:ea typeface="Cambria" pitchFamily="34" charset="-122"/>
                 <a:cs typeface="Cambria" pitchFamily="34" charset="-120"/>
               </a:rPr>
-              <a:t>What-if on their twin, nudges in their language</a:t>
+              <a:t>The virtual patient, in 3D</a:t>
             </a:r>
             <a:endParaRPr lang="en-US" sz="3000" dirty="0"/>
+          </a:p>
+        </p:txBody>
+      </p:sp>
+      <p:sp>
+        <p:nvSpPr>
+          <p:cNvPr id="3" name="Text 1"/>
+          <p:cNvSpPr txBox="1"/>
+          <p:nvPr/>
+        </p:nvSpPr>
+        <p:spPr>
+          <a:xfrm>
+            <a:off x="457200" y="987552"/>
+            <a:ext cx="9692640" cy="365760"/>
+          </a:xfrm>
+          <a:prstGeom prst="rect">
+            <a:avLst/>
+          </a:prstGeom>
+          <a:noFill/>
+          <a:ln/>
+        </p:spPr>
+        <p:txBody>
+          <a:bodyPr wrap="square" lIns="0" tIns="0" rIns="0" bIns="0" rtlCol="0" anchor="ctr"/>
+          <a:lstStyle/>
+          <a:p>
+            <a:pPr indent="0" marL="0">
+              <a:buNone/>
+            </a:pPr>
+            <a:r>
+              <a:rPr lang="en-US" sz="1500" dirty="0">
+                <a:solidFill>
+                  <a:srgbClr val="4A5260"/>
+                </a:solidFill>
+              </a:rPr>
+              <a:t>A real human body shaped like the patient, with anatomical organs coloured by the twin</a:t>
+            </a:r>
+            <a:endParaRPr lang="en-US" sz="1500" dirty="0"/>
           </a:p>
         </p:txBody>
       </p:sp>
       <p:pic>
         <p:nvPicPr>
-          <p:cNvPr id="3" name="whatif_crop.png" descr="F:\Digital Twin\docs\screenshots\whatif_crop.png">    </p:cNvPr>
+          <p:cNvPr id="4" name="vp3d_crop.png" descr="F:\Digital Twin\docs\screenshots\vp3d_crop.png">    </p:cNvPr>
           <p:cNvPicPr>
             <a:picLocks noChangeAspect="1"/>
           </p:cNvPicPr>
@@ -10391,37 +10517,108 @@
         </p:blipFill>
         <p:spPr>
           <a:xfrm>
-            <a:off x="457200" y="1188720"/>
-            <a:ext cx="8138160" cy="5120640"/>
+            <a:off x="457200" y="1417320"/>
+            <a:ext cx="7680960" cy="4480560"/>
           </a:xfrm>
           <a:prstGeom prst="rect">
             <a:avLst/>
           </a:prstGeom>
         </p:spPr>
       </p:pic>
-      <p:pic>
-        <p:nvPicPr>
-          <p:cNvPr id="4" name="companion_hi.png" descr="F:\Digital Twin\docs\screenshots\companion_hi.png">    </p:cNvPr>
-          <p:cNvPicPr>
-            <a:picLocks noChangeAspect="1"/>
-          </p:cNvPicPr>
-          <p:nvPr/>
-        </p:nvPicPr>
-        <p:blipFill>
-          <a:blip r:embed="rId2"/>
-          <a:srcRect l="0" r="0" t="0" b="0"/>
-          <a:stretch/>
-        </p:blipFill>
-        <p:spPr>
-          <a:xfrm>
-            <a:off x="8869680" y="1188720"/>
-            <a:ext cx="2834640" cy="5120640"/>
-          </a:xfrm>
-          <a:prstGeom prst="rect">
-            <a:avLst/>
-          </a:prstGeom>
-        </p:spPr>
-      </p:pic>
+      <p:sp>
+        <p:nvSpPr>
+          <p:cNvPr id="5" name="Text 2"/>
+          <p:cNvSpPr txBox="1"/>
+          <p:nvPr/>
+        </p:nvSpPr>
+        <p:spPr>
+          <a:xfrm>
+            <a:off x="8412480" y="1463040"/>
+            <a:ext cx="3291840" cy="4480560"/>
+          </a:xfrm>
+          <a:prstGeom prst="rect">
+            <a:avLst/>
+          </a:prstGeom>
+          <a:noFill/>
+          <a:ln/>
+        </p:spPr>
+        <p:txBody>
+          <a:bodyPr wrap="square" lIns="0" tIns="0" rIns="0" bIns="0" rtlCol="0" anchor="t"/>
+          <a:lstStyle/>
+          <a:p>
+            <a:pPr marL="342900" indent="-342900">
+              <a:spcAft>
+                <a:spcPts val="800"/>
+              </a:spcAft>
+              <a:buSzPct val="100000"/>
+              <a:buChar char="•"/>
+            </a:pPr>
+            <a:r>
+              <a:rPr lang="en-US" sz="1400" dirty="0">
+                <a:solidFill>
+                  <a:srgbClr val="222833"/>
+                </a:solidFill>
+              </a:rPr>
+              <a:t>Body from the MakeHuman mesh (CC0), shaped from the patient's sex and BMI in the EHR</a:t>
+            </a:r>
+            <a:endParaRPr lang="en-US" sz="1400" dirty="0"/>
+          </a:p>
+          <a:p>
+            <a:pPr marL="342900" indent="-342900">
+              <a:spcAft>
+                <a:spcPts val="800"/>
+              </a:spcAft>
+              <a:buSzPct val="100000"/>
+              <a:buChar char="•"/>
+            </a:pPr>
+            <a:r>
+              <a:rPr lang="en-US" sz="1400" dirty="0">
+                <a:solidFill>
+                  <a:srgbClr val="222833"/>
+                </a:solidFill>
+              </a:rPr>
+              <a:t>Anatomical organs from BodyParts3D, placed by skeletal landmarks (2 cm mean fit error)</a:t>
+            </a:r>
+            <a:endParaRPr lang="en-US" sz="1400" dirty="0"/>
+          </a:p>
+          <a:p>
+            <a:pPr marL="342900" indent="-342900">
+              <a:spcAft>
+                <a:spcPts val="800"/>
+              </a:spcAft>
+              <a:buSzPct val="100000"/>
+              <a:buChar char="•"/>
+            </a:pPr>
+            <a:r>
+              <a:rPr lang="en-US" sz="1400" dirty="0">
+                <a:solidFill>
+                  <a:srgbClr val="222833"/>
+                </a:solidFill>
+              </a:rPr>
+              <a:t>Each organ coloured by the twin's estimate: beta-cell response, insulin sensitivity, fasting set-point, absorption, kidney function</a:t>
+            </a:r>
+            <a:endParaRPr lang="en-US" sz="1400" dirty="0"/>
+          </a:p>
+          <a:p>
+            <a:pPr marL="342900" indent="-342900">
+              <a:spcAft>
+                <a:spcPts val="800"/>
+              </a:spcAft>
+              <a:buSzPct val="100000"/>
+              <a:buChar char="•"/>
+            </a:pPr>
+            <a:r>
+              <a:rPr lang="en-US" sz="1400" dirty="0">
+                <a:solidFill>
+                  <a:srgbClr val="222833"/>
+                </a:solidFill>
+              </a:rPr>
+              <a:t>The heart beats at the patient's own night heart rate; rotate, zoom, hover an organ</a:t>
+            </a:r>
+            <a:endParaRPr lang="en-US" sz="1400" dirty="0"/>
+          </a:p>
+        </p:txBody>
+      </p:sp>
       <p:sp>
         <p:nvSpPr>
           <p:cNvPr id="25" name="Slide Number Placeholder 0"/>
@@ -10527,51 +10724,15 @@
                 <a:ea typeface="Cambria" pitchFamily="34" charset="-122"/>
                 <a:cs typeface="Cambria" pitchFamily="34" charset="-120"/>
               </a:rPr>
-              <a:t>Try a prescription on the twin first</a:t>
+              <a:t>What-if on their twin, nudges in their language</a:t>
             </a:r>
             <a:endParaRPr lang="en-US" sz="3000" dirty="0"/>
-          </a:p>
-        </p:txBody>
-      </p:sp>
-      <p:sp>
-        <p:nvSpPr>
-          <p:cNvPr id="3" name="Text 1"/>
-          <p:cNvSpPr txBox="1"/>
-          <p:nvPr/>
-        </p:nvSpPr>
-        <p:spPr>
-          <a:xfrm>
-            <a:off x="457200" y="987552"/>
-            <a:ext cx="9692640" cy="365760"/>
-          </a:xfrm>
-          <a:prstGeom prst="rect">
-            <a:avLst/>
-          </a:prstGeom>
-          <a:noFill/>
-          <a:ln/>
-        </p:spPr>
-        <p:txBody>
-          <a:bodyPr wrap="square" lIns="0" tIns="0" rIns="0" bIns="0" rtlCol="0" anchor="ctr"/>
-          <a:lstStyle/>
-          <a:p>
-            <a:pPr indent="0" marL="0">
-              <a:buNone/>
-            </a:pPr>
-            <a:r>
-              <a:rPr lang="en-US" sz="1500" dirty="0">
-                <a:solidFill>
-                  <a:srgbClr val="4A5260"/>
-                </a:solidFill>
-              </a:rPr>
-              <a:t>Neha Agarwal: SGLT2 inhibitor with eGFR 51. Should it be stopped?</a:t>
-            </a:r>
-            <a:endParaRPr lang="en-US" sz="1500" dirty="0"/>
           </a:p>
         </p:txBody>
       </p:sp>
       <p:pic>
         <p:nvPicPr>
-          <p:cNvPr id="4" name="therapy_crop.png" descr="F:\Digital Twin\docs\screenshots\therapy_crop.png">    </p:cNvPr>
+          <p:cNvPr id="3" name="whatif_crop.png" descr="F:\Digital Twin\docs\screenshots\whatif_crop.png">    </p:cNvPr>
           <p:cNvPicPr>
             <a:picLocks noChangeAspect="1"/>
           </p:cNvPicPr>
@@ -10584,239 +10745,37 @@
         </p:blipFill>
         <p:spPr>
           <a:xfrm>
-            <a:off x="457200" y="1371600"/>
-            <a:ext cx="11247120" cy="3429000"/>
+            <a:off x="457200" y="1188720"/>
+            <a:ext cx="8138160" cy="5120640"/>
           </a:xfrm>
           <a:prstGeom prst="rect">
             <a:avLst/>
           </a:prstGeom>
         </p:spPr>
       </p:pic>
-      <p:sp>
-        <p:nvSpPr>
-          <p:cNvPr id="5" name="Text 2"/>
-          <p:cNvSpPr txBox="1"/>
-          <p:nvPr/>
-        </p:nvSpPr>
-        <p:spPr>
-          <a:xfrm>
-            <a:off x="457200" y="4846320"/>
-            <a:ext cx="3657600" cy="685800"/>
-          </a:xfrm>
-          <a:prstGeom prst="rect">
-            <a:avLst/>
-          </a:prstGeom>
-          <a:noFill/>
-          <a:ln/>
-        </p:spPr>
-        <p:txBody>
-          <a:bodyPr wrap="square" lIns="0" tIns="0" rIns="0" bIns="0" rtlCol="0" anchor="b"/>
-          <a:lstStyle/>
-          <a:p>
-            <a:pPr indent="0" marL="0">
-              <a:buNone/>
-            </a:pPr>
-            <a:r>
-              <a:rPr lang="en-US" sz="4000" b="1" dirty="0">
-                <a:solidFill>
-                  <a:srgbClr val="14284B"/>
-                </a:solidFill>
-                <a:latin typeface="Calibri" pitchFamily="34" charset="0"/>
-                <a:ea typeface="Calibri" pitchFamily="34" charset="-122"/>
-                <a:cs typeface="Calibri" pitchFamily="34" charset="-120"/>
-              </a:rPr>
-              <a:t>86.5% → 72.6%</a:t>
-            </a:r>
-            <a:endParaRPr lang="en-US" sz="4000" dirty="0"/>
-          </a:p>
-        </p:txBody>
-      </p:sp>
-      <p:sp>
-        <p:nvSpPr>
-          <p:cNvPr id="6" name="Text 3"/>
-          <p:cNvSpPr txBox="1"/>
-          <p:nvPr/>
-        </p:nvSpPr>
-        <p:spPr>
-          <a:xfrm>
-            <a:off x="457200" y="5559552"/>
-            <a:ext cx="3657600" cy="548640"/>
-          </a:xfrm>
-          <a:prstGeom prst="rect">
-            <a:avLst/>
-          </a:prstGeom>
-          <a:noFill/>
-          <a:ln/>
-        </p:spPr>
-        <p:txBody>
-          <a:bodyPr wrap="square" lIns="0" tIns="0" rIns="0" bIns="0" rtlCol="0" anchor="t"/>
-          <a:lstStyle/>
-          <a:p>
-            <a:pPr indent="0" marL="0">
-              <a:buNone/>
-            </a:pPr>
-            <a:r>
-              <a:rPr lang="en-US" sz="1300" dirty="0">
-                <a:solidFill>
-                  <a:srgbClr val="4A5260"/>
-                </a:solidFill>
-              </a:rPr>
-              <a:t>time in range over the next 24 h if the SGLT2 inhibitor is stopped</a:t>
-            </a:r>
-            <a:endParaRPr lang="en-US" sz="1300" dirty="0"/>
-          </a:p>
-        </p:txBody>
-      </p:sp>
-      <p:sp>
-        <p:nvSpPr>
-          <p:cNvPr id="7" name="Text 4"/>
-          <p:cNvSpPr txBox="1"/>
-          <p:nvPr/>
-        </p:nvSpPr>
-        <p:spPr>
-          <a:xfrm>
-            <a:off x="4343400" y="4846320"/>
-            <a:ext cx="3657600" cy="685800"/>
-          </a:xfrm>
-          <a:prstGeom prst="rect">
-            <a:avLst/>
-          </a:prstGeom>
-          <a:noFill/>
-          <a:ln/>
-        </p:spPr>
-        <p:txBody>
-          <a:bodyPr wrap="square" lIns="0" tIns="0" rIns="0" bIns="0" rtlCol="0" anchor="b"/>
-          <a:lstStyle/>
-          <a:p>
-            <a:pPr indent="0" marL="0">
-              <a:buNone/>
-            </a:pPr>
-            <a:r>
-              <a:rPr lang="en-US" sz="4000" b="1" dirty="0">
-                <a:solidFill>
-                  <a:srgbClr val="14284B"/>
-                </a:solidFill>
-                <a:latin typeface="Calibri" pitchFamily="34" charset="0"/>
-                <a:ea typeface="Calibri" pitchFamily="34" charset="-122"/>
-                <a:cs typeface="Calibri" pitchFamily="34" charset="-120"/>
-              </a:rPr>
-              <a:t>88.5%</a:t>
-            </a:r>
-            <a:endParaRPr lang="en-US" sz="4000" dirty="0"/>
-          </a:p>
-        </p:txBody>
-      </p:sp>
-      <p:sp>
-        <p:nvSpPr>
-          <p:cNvPr id="8" name="Text 5"/>
-          <p:cNvSpPr txBox="1"/>
-          <p:nvPr/>
-        </p:nvSpPr>
-        <p:spPr>
-          <a:xfrm>
-            <a:off x="4343400" y="5559552"/>
-            <a:ext cx="3657600" cy="548640"/>
-          </a:xfrm>
-          <a:prstGeom prst="rect">
-            <a:avLst/>
-          </a:prstGeom>
-          <a:noFill/>
-          <a:ln/>
-        </p:spPr>
-        <p:txBody>
-          <a:bodyPr wrap="square" lIns="0" tIns="0" rIns="0" bIns="0" rtlCol="0" anchor="t"/>
-          <a:lstStyle/>
-          <a:p>
-            <a:pPr indent="0" marL="0">
-              <a:buNone/>
-            </a:pPr>
-            <a:r>
-              <a:rPr lang="en-US" sz="1300" dirty="0">
-                <a:solidFill>
-                  <a:srgbClr val="4A5260"/>
-                </a:solidFill>
-              </a:rPr>
-              <a:t>keeping it and adding a DPP-4 inhibitor: as much as doubling Gliclazide (88.5%)</a:t>
-            </a:r>
-            <a:endParaRPr lang="en-US" sz="1300" dirty="0"/>
-          </a:p>
-        </p:txBody>
-      </p:sp>
-      <p:sp>
-        <p:nvSpPr>
-          <p:cNvPr id="9" name="Text 6"/>
-          <p:cNvSpPr txBox="1"/>
-          <p:nvPr/>
-        </p:nvSpPr>
-        <p:spPr>
-          <a:xfrm>
-            <a:off x="8229600" y="4846320"/>
-            <a:ext cx="3474720" cy="685800"/>
-          </a:xfrm>
-          <a:prstGeom prst="rect">
-            <a:avLst/>
-          </a:prstGeom>
-          <a:noFill/>
-          <a:ln/>
-        </p:spPr>
-        <p:txBody>
-          <a:bodyPr wrap="square" lIns="0" tIns="0" rIns="0" bIns="0" rtlCol="0" anchor="b"/>
-          <a:lstStyle/>
-          <a:p>
-            <a:pPr indent="0" marL="0">
-              <a:buNone/>
-            </a:pPr>
-            <a:r>
-              <a:rPr lang="en-US" sz="4000" b="1" dirty="0">
-                <a:solidFill>
-                  <a:srgbClr val="14284B"/>
-                </a:solidFill>
-                <a:latin typeface="Calibri" pitchFamily="34" charset="0"/>
-                <a:ea typeface="Calibri" pitchFamily="34" charset="-122"/>
-                <a:cs typeface="Calibri" pitchFamily="34" charset="-120"/>
-              </a:rPr>
-              <a:t>11.4 mg/dL</a:t>
-            </a:r>
-            <a:endParaRPr lang="en-US" sz="4000" dirty="0"/>
-          </a:p>
-        </p:txBody>
-      </p:sp>
-      <p:sp>
-        <p:nvSpPr>
-          <p:cNvPr id="10" name="Text 7"/>
-          <p:cNvSpPr txBox="1"/>
-          <p:nvPr/>
-        </p:nvSpPr>
-        <p:spPr>
-          <a:xfrm>
-            <a:off x="8229600" y="5559552"/>
-            <a:ext cx="3474720" cy="548640"/>
-          </a:xfrm>
-          <a:prstGeom prst="rect">
-            <a:avLst/>
-          </a:prstGeom>
-          <a:noFill/>
-          <a:ln/>
-        </p:spPr>
-        <p:txBody>
-          <a:bodyPr wrap="square" lIns="0" tIns="0" rIns="0" bIns="0" rtlCol="0" anchor="t"/>
-          <a:lstStyle/>
-          <a:p>
-            <a:pPr indent="0" marL="0">
-              <a:buNone/>
-            </a:pPr>
-            <a:r>
-              <a:rPr lang="en-US" sz="1300" dirty="0">
-                <a:solidFill>
-                  <a:srgbClr val="4A5260"/>
-                </a:solidFill>
-              </a:rPr>
-              <a:t>trust check: the twin's replay of the last 24 h vs CGM (agreement good)</a:t>
-            </a:r>
-            <a:endParaRPr lang="en-US" sz="1300" dirty="0"/>
-          </a:p>
-        </p:txBody>
-      </p:sp>
+      <p:pic>
+        <p:nvPicPr>
+          <p:cNvPr id="4" name="companion_hi.png" descr="F:\Digital Twin\docs\screenshots\companion_hi.png">    </p:cNvPr>
+          <p:cNvPicPr>
+            <a:picLocks noChangeAspect="1"/>
+          </p:cNvPicPr>
+          <p:nvPr/>
+        </p:nvPicPr>
+        <p:blipFill>
+          <a:blip r:embed="rId2"/>
+          <a:srcRect l="0" r="0" t="0" b="0"/>
+          <a:stretch/>
+        </p:blipFill>
+        <p:spPr>
+          <a:xfrm>
+            <a:off x="8869680" y="1188720"/>
+            <a:ext cx="2834640" cy="5120640"/>
+          </a:xfrm>
+          <a:prstGeom prst="rect">
+            <a:avLst/>
+          </a:prstGeom>
+        </p:spPr>
+      </p:pic>
       <p:sp>
         <p:nvSpPr>
           <p:cNvPr id="25" name="Slide Number Placeholder 0"/>
@@ -10922,7 +10881,7 @@
                 <a:ea typeface="Cambria" pitchFamily="34" charset="-122"/>
                 <a:cs typeface="Cambria" pitchFamily="34" charset="-120"/>
               </a:rPr>
-              <a:t>Responsible by design</a:t>
+              <a:t>Try a prescription on the twin first</a:t>
             </a:r>
             <a:endParaRPr lang="en-US" sz="3000" dirty="0"/>
           </a:p>
@@ -10930,39 +10889,14 @@
       </p:sp>
       <p:sp>
         <p:nvSpPr>
-          <p:cNvPr id="3" name="Shape 1"/>
-          <p:cNvSpPr/>
-          <p:nvPr/>
-        </p:nvSpPr>
-        <p:spPr>
-          <a:xfrm>
-            <a:off x="502920" y="1463040"/>
-            <a:ext cx="457200" cy="457200"/>
-          </a:xfrm>
-          <a:prstGeom prst="ellipse">
-            <a:avLst/>
-          </a:prstGeom>
-          <a:solidFill>
-            <a:srgbClr val="E8A317"/>
-          </a:solidFill>
-          <a:ln w="12700">
-            <a:solidFill>
-              <a:srgbClr val="E8A317"/>
-            </a:solidFill>
-            <a:prstDash val="solid"/>
-          </a:ln>
-        </p:spPr>
-      </p:sp>
-      <p:sp>
-        <p:nvSpPr>
-          <p:cNvPr id="4" name="Text 2"/>
+          <p:cNvPr id="3" name="Text 1"/>
           <p:cNvSpPr txBox="1"/>
           <p:nvPr/>
         </p:nvSpPr>
         <p:spPr>
           <a:xfrm>
-            <a:off x="502920" y="1463040"/>
-            <a:ext cx="457200" cy="457200"/>
+            <a:off x="457200" y="987552"/>
+            <a:ext cx="9692640" cy="365760"/>
           </a:xfrm>
           <a:prstGeom prst="rect">
             <a:avLst/>
@@ -10974,31 +10908,93 @@
           <a:bodyPr wrap="square" lIns="0" tIns="0" rIns="0" bIns="0" rtlCol="0" anchor="ctr"/>
           <a:lstStyle/>
           <a:p>
-            <a:pPr algn="ctr" indent="0" marL="0">
-              <a:buNone/>
-            </a:pPr>
-            <a:r>
-              <a:rPr lang="en-US" sz="1400" b="1" dirty="0">
+            <a:pPr indent="0" marL="0">
+              <a:buNone/>
+            </a:pPr>
+            <a:r>
+              <a:rPr lang="en-US" sz="1500" dirty="0">
+                <a:solidFill>
+                  <a:srgbClr val="4A5260"/>
+                </a:solidFill>
+              </a:rPr>
+              <a:t>Neha Agarwal: SGLT2 inhibitor with eGFR 51. Should it be stopped?</a:t>
+            </a:r>
+            <a:endParaRPr lang="en-US" sz="1500" dirty="0"/>
+          </a:p>
+        </p:txBody>
+      </p:sp>
+      <p:pic>
+        <p:nvPicPr>
+          <p:cNvPr id="4" name="therapy_crop.png" descr="F:\Digital Twin\docs\screenshots\therapy_crop.png">    </p:cNvPr>
+          <p:cNvPicPr>
+            <a:picLocks noChangeAspect="1"/>
+          </p:cNvPicPr>
+          <p:nvPr/>
+        </p:nvPicPr>
+        <p:blipFill>
+          <a:blip r:embed="rId1"/>
+          <a:srcRect l="0" r="0" t="0" b="0"/>
+          <a:stretch/>
+        </p:blipFill>
+        <p:spPr>
+          <a:xfrm>
+            <a:off x="457200" y="1371600"/>
+            <a:ext cx="11247120" cy="3429000"/>
+          </a:xfrm>
+          <a:prstGeom prst="rect">
+            <a:avLst/>
+          </a:prstGeom>
+        </p:spPr>
+      </p:pic>
+      <p:sp>
+        <p:nvSpPr>
+          <p:cNvPr id="5" name="Text 2"/>
+          <p:cNvSpPr txBox="1"/>
+          <p:nvPr/>
+        </p:nvSpPr>
+        <p:spPr>
+          <a:xfrm>
+            <a:off x="457200" y="4846320"/>
+            <a:ext cx="3657600" cy="685800"/>
+          </a:xfrm>
+          <a:prstGeom prst="rect">
+            <a:avLst/>
+          </a:prstGeom>
+          <a:noFill/>
+          <a:ln/>
+        </p:spPr>
+        <p:txBody>
+          <a:bodyPr wrap="square" lIns="0" tIns="0" rIns="0" bIns="0" rtlCol="0" anchor="b"/>
+          <a:lstStyle/>
+          <a:p>
+            <a:pPr indent="0" marL="0">
+              <a:buNone/>
+            </a:pPr>
+            <a:r>
+              <a:rPr lang="en-US" sz="4000" b="1" dirty="0">
                 <a:solidFill>
                   <a:srgbClr val="14284B"/>
                 </a:solidFill>
-              </a:rPr>
-              <a:t>1</a:t>
-            </a:r>
-            <a:endParaRPr lang="en-US" sz="1400" dirty="0"/>
-          </a:p>
-        </p:txBody>
-      </p:sp>
-      <p:sp>
-        <p:nvSpPr>
-          <p:cNvPr id="5" name="Text 3"/>
+                <a:latin typeface="Calibri" pitchFamily="34" charset="0"/>
+                <a:ea typeface="Calibri" pitchFamily="34" charset="-122"/>
+                <a:cs typeface="Calibri" pitchFamily="34" charset="-120"/>
+              </a:rPr>
+              <a:t>86.5% → 72.6%</a:t>
+            </a:r>
+            <a:endParaRPr lang="en-US" sz="4000" dirty="0"/>
+          </a:p>
+        </p:txBody>
+      </p:sp>
+      <p:sp>
+        <p:nvSpPr>
+          <p:cNvPr id="6" name="Text 3"/>
           <p:cNvSpPr txBox="1"/>
           <p:nvPr/>
         </p:nvSpPr>
         <p:spPr>
           <a:xfrm>
-            <a:off x="1188720" y="1371600"/>
-            <a:ext cx="10515600" cy="868680"/>
+            <a:off x="457200" y="5559552"/>
+            <a:ext cx="3657600" cy="548640"/>
           </a:xfrm>
           <a:prstGeom prst="rect">
             <a:avLst/>
@@ -11014,66 +11010,102 @@
               <a:buNone/>
             </a:pPr>
             <a:r>
-              <a:rPr lang="en-US" sz="1600" b="1" dirty="0">
+              <a:rPr lang="en-US" sz="1300" dirty="0">
+                <a:solidFill>
+                  <a:srgbClr val="4A5260"/>
+                </a:solidFill>
+              </a:rPr>
+              <a:t>time in range over the next 24 h if the SGLT2 inhibitor is stopped</a:t>
+            </a:r>
+            <a:endParaRPr lang="en-US" sz="1300" dirty="0"/>
+          </a:p>
+        </p:txBody>
+      </p:sp>
+      <p:sp>
+        <p:nvSpPr>
+          <p:cNvPr id="7" name="Text 4"/>
+          <p:cNvSpPr txBox="1"/>
+          <p:nvPr/>
+        </p:nvSpPr>
+        <p:spPr>
+          <a:xfrm>
+            <a:off x="4343400" y="4846320"/>
+            <a:ext cx="3657600" cy="685800"/>
+          </a:xfrm>
+          <a:prstGeom prst="rect">
+            <a:avLst/>
+          </a:prstGeom>
+          <a:noFill/>
+          <a:ln/>
+        </p:spPr>
+        <p:txBody>
+          <a:bodyPr wrap="square" lIns="0" tIns="0" rIns="0" bIns="0" rtlCol="0" anchor="b"/>
+          <a:lstStyle/>
+          <a:p>
+            <a:pPr indent="0" marL="0">
+              <a:buNone/>
+            </a:pPr>
+            <a:r>
+              <a:rPr lang="en-US" sz="4000" b="1" dirty="0">
                 <a:solidFill>
                   <a:srgbClr val="14284B"/>
                 </a:solidFill>
-              </a:rPr>
-              <a:t>DPDP Act 2023</a:t>
-            </a:r>
-            <a:endParaRPr lang="en-US" sz="1600" dirty="0"/>
-          </a:p>
+                <a:latin typeface="Calibri" pitchFamily="34" charset="0"/>
+                <a:ea typeface="Calibri" pitchFamily="34" charset="-122"/>
+                <a:cs typeface="Calibri" pitchFamily="34" charset="-120"/>
+              </a:rPr>
+              <a:t>88.5%</a:t>
+            </a:r>
+            <a:endParaRPr lang="en-US" sz="4000" dirty="0"/>
+          </a:p>
+        </p:txBody>
+      </p:sp>
+      <p:sp>
+        <p:nvSpPr>
+          <p:cNvPr id="8" name="Text 5"/>
+          <p:cNvSpPr txBox="1"/>
+          <p:nvPr/>
+        </p:nvSpPr>
+        <p:spPr>
+          <a:xfrm>
+            <a:off x="4343400" y="5559552"/>
+            <a:ext cx="3657600" cy="548640"/>
+          </a:xfrm>
+          <a:prstGeom prst="rect">
+            <a:avLst/>
+          </a:prstGeom>
+          <a:noFill/>
+          <a:ln/>
+        </p:spPr>
+        <p:txBody>
+          <a:bodyPr wrap="square" lIns="0" tIns="0" rIns="0" bIns="0" rtlCol="0" anchor="t"/>
+          <a:lstStyle/>
           <a:p>
             <a:pPr indent="0" marL="0">
               <a:buNone/>
             </a:pPr>
             <a:r>
-              <a:rPr lang="en-US" sz="1400" dirty="0">
+              <a:rPr lang="en-US" sz="1300" dirty="0">
                 <a:solidFill>
                   <a:srgbClr val="4A5260"/>
                 </a:solidFill>
               </a:rPr>
-              <a:t>Consent artefacts, purpose limitation, data minimisation, purpose-tagged audit trail; synthetic and de-identified data only</a:t>
-            </a:r>
-            <a:endParaRPr lang="en-US" sz="1600" dirty="0"/>
-          </a:p>
-        </p:txBody>
-      </p:sp>
-      <p:sp>
-        <p:nvSpPr>
-          <p:cNvPr id="6" name="Shape 4"/>
-          <p:cNvSpPr/>
-          <p:nvPr/>
-        </p:nvSpPr>
-        <p:spPr>
-          <a:xfrm>
-            <a:off x="502920" y="2423160"/>
-            <a:ext cx="457200" cy="457200"/>
-          </a:xfrm>
-          <a:prstGeom prst="ellipse">
-            <a:avLst/>
-          </a:prstGeom>
-          <a:solidFill>
-            <a:srgbClr val="14284B"/>
-          </a:solidFill>
-          <a:ln w="12700">
-            <a:solidFill>
-              <a:srgbClr val="14284B"/>
-            </a:solidFill>
-            <a:prstDash val="solid"/>
-          </a:ln>
-        </p:spPr>
-      </p:sp>
-      <p:sp>
-        <p:nvSpPr>
-          <p:cNvPr id="7" name="Text 5"/>
+              <a:t>keeping it and adding a DPP-4 inhibitor: as much as doubling Gliclazide (88.5%)</a:t>
+            </a:r>
+            <a:endParaRPr lang="en-US" sz="1300" dirty="0"/>
+          </a:p>
+        </p:txBody>
+      </p:sp>
+      <p:sp>
+        <p:nvSpPr>
+          <p:cNvPr id="9" name="Text 6"/>
           <p:cNvSpPr txBox="1"/>
           <p:nvPr/>
         </p:nvSpPr>
         <p:spPr>
           <a:xfrm>
-            <a:off x="502920" y="2423160"/>
-            <a:ext cx="457200" cy="457200"/>
+            <a:off x="8229600" y="4846320"/>
+            <a:ext cx="3474720" cy="685800"/>
           </a:xfrm>
           <a:prstGeom prst="rect">
             <a:avLst/>
@@ -11082,34 +11114,37 @@
           <a:ln/>
         </p:spPr>
         <p:txBody>
-          <a:bodyPr wrap="square" lIns="0" tIns="0" rIns="0" bIns="0" rtlCol="0" anchor="ctr"/>
-          <a:lstStyle/>
-          <a:p>
-            <a:pPr algn="ctr" indent="0" marL="0">
-              <a:buNone/>
-            </a:pPr>
-            <a:r>
-              <a:rPr lang="en-US" sz="1400" b="1" dirty="0">
-                <a:solidFill>
-                  <a:srgbClr val="FFFFFF"/>
-                </a:solidFill>
-              </a:rPr>
-              <a:t>2</a:t>
-            </a:r>
-            <a:endParaRPr lang="en-US" sz="1400" dirty="0"/>
-          </a:p>
-        </p:txBody>
-      </p:sp>
-      <p:sp>
-        <p:nvSpPr>
-          <p:cNvPr id="8" name="Text 6"/>
+          <a:bodyPr wrap="square" lIns="0" tIns="0" rIns="0" bIns="0" rtlCol="0" anchor="b"/>
+          <a:lstStyle/>
+          <a:p>
+            <a:pPr indent="0" marL="0">
+              <a:buNone/>
+            </a:pPr>
+            <a:r>
+              <a:rPr lang="en-US" sz="4000" b="1" dirty="0">
+                <a:solidFill>
+                  <a:srgbClr val="14284B"/>
+                </a:solidFill>
+                <a:latin typeface="Calibri" pitchFamily="34" charset="0"/>
+                <a:ea typeface="Calibri" pitchFamily="34" charset="-122"/>
+                <a:cs typeface="Calibri" pitchFamily="34" charset="-120"/>
+              </a:rPr>
+              <a:t>11.4 mg/dL</a:t>
+            </a:r>
+            <a:endParaRPr lang="en-US" sz="4000" dirty="0"/>
+          </a:p>
+        </p:txBody>
+      </p:sp>
+      <p:sp>
+        <p:nvSpPr>
+          <p:cNvPr id="10" name="Text 7"/>
           <p:cNvSpPr txBox="1"/>
           <p:nvPr/>
         </p:nvSpPr>
         <p:spPr>
           <a:xfrm>
-            <a:off x="1188720" y="2331720"/>
-            <a:ext cx="10515600" cy="868680"/>
+            <a:off x="8229600" y="5559552"/>
+            <a:ext cx="3474720" cy="548640"/>
           </a:xfrm>
           <a:prstGeom prst="rect">
             <a:avLst/>
@@ -11125,361 +11160,14 @@
               <a:buNone/>
             </a:pPr>
             <a:r>
-              <a:rPr lang="en-US" sz="1600" b="1" dirty="0">
-                <a:solidFill>
-                  <a:srgbClr val="14284B"/>
-                </a:solidFill>
-              </a:rPr>
-              <a:t>ABDM-ready interoperability</a:t>
-            </a:r>
-            <a:endParaRPr lang="en-US" sz="1600" dirty="0"/>
-          </a:p>
-          <a:p>
-            <a:pPr indent="0" marL="0">
-              <a:buNone/>
-            </a:pPr>
-            <a:r>
-              <a:rPr lang="en-US" sz="1400" dirty="0">
+              <a:rPr lang="en-US" sz="1300" dirty="0">
                 <a:solidFill>
                   <a:srgbClr val="4A5260"/>
                 </a:solidFill>
               </a:rPr>
-              <a:t>FHIR R4 with SNOMED CT, LOINC, WHO ATC; CGM as SampledData; the forecast exported as a RiskAssessment</a:t>
-            </a:r>
-            <a:endParaRPr lang="en-US" sz="1600" dirty="0"/>
-          </a:p>
-        </p:txBody>
-      </p:sp>
-      <p:sp>
-        <p:nvSpPr>
-          <p:cNvPr id="9" name="Shape 7"/>
-          <p:cNvSpPr/>
-          <p:nvPr/>
-        </p:nvSpPr>
-        <p:spPr>
-          <a:xfrm>
-            <a:off x="502920" y="3383280"/>
-            <a:ext cx="457200" cy="457200"/>
-          </a:xfrm>
-          <a:prstGeom prst="ellipse">
-            <a:avLst/>
-          </a:prstGeom>
-          <a:solidFill>
-            <a:srgbClr val="14284B"/>
-          </a:solidFill>
-          <a:ln w="12700">
-            <a:solidFill>
-              <a:srgbClr val="14284B"/>
-            </a:solidFill>
-            <a:prstDash val="solid"/>
-          </a:ln>
-        </p:spPr>
-      </p:sp>
-      <p:sp>
-        <p:nvSpPr>
-          <p:cNvPr id="10" name="Text 8"/>
-          <p:cNvSpPr txBox="1"/>
-          <p:nvPr/>
-        </p:nvSpPr>
-        <p:spPr>
-          <a:xfrm>
-            <a:off x="502920" y="3383280"/>
-            <a:ext cx="457200" cy="457200"/>
-          </a:xfrm>
-          <a:prstGeom prst="rect">
-            <a:avLst/>
-          </a:prstGeom>
-          <a:noFill/>
-          <a:ln/>
-        </p:spPr>
-        <p:txBody>
-          <a:bodyPr wrap="square" lIns="0" tIns="0" rIns="0" bIns="0" rtlCol="0" anchor="ctr"/>
-          <a:lstStyle/>
-          <a:p>
-            <a:pPr algn="ctr" indent="0" marL="0">
-              <a:buNone/>
-            </a:pPr>
-            <a:r>
-              <a:rPr lang="en-US" sz="1400" b="1" dirty="0">
-                <a:solidFill>
-                  <a:srgbClr val="FFFFFF"/>
-                </a:solidFill>
-              </a:rPr>
-              <a:t>3</a:t>
-            </a:r>
-            <a:endParaRPr lang="en-US" sz="1400" dirty="0"/>
-          </a:p>
-        </p:txBody>
-      </p:sp>
-      <p:sp>
-        <p:nvSpPr>
-          <p:cNvPr id="11" name="Text 9"/>
-          <p:cNvSpPr txBox="1"/>
-          <p:nvPr/>
-        </p:nvSpPr>
-        <p:spPr>
-          <a:xfrm>
-            <a:off x="1188720" y="3291840"/>
-            <a:ext cx="10515600" cy="868680"/>
-          </a:xfrm>
-          <a:prstGeom prst="rect">
-            <a:avLst/>
-          </a:prstGeom>
-          <a:noFill/>
-          <a:ln/>
-        </p:spPr>
-        <p:txBody>
-          <a:bodyPr wrap="square" lIns="0" tIns="0" rIns="0" bIns="0" rtlCol="0" anchor="t"/>
-          <a:lstStyle/>
-          <a:p>
-            <a:pPr indent="0" marL="0">
-              <a:buNone/>
-            </a:pPr>
-            <a:r>
-              <a:rPr lang="en-US" sz="1600" b="1" dirty="0">
-                <a:solidFill>
-                  <a:srgbClr val="14284B"/>
-                </a:solidFill>
-              </a:rPr>
-              <a:t>Explainable</a:t>
-            </a:r>
-            <a:endParaRPr lang="en-US" sz="1600" dirty="0"/>
-          </a:p>
-          <a:p>
-            <a:pPr indent="0" marL="0">
-              <a:buNone/>
-            </a:pPr>
-            <a:r>
-              <a:rPr lang="en-US" sz="1400" dirty="0">
-                <a:solidFill>
-                  <a:srgbClr val="4A5260"/>
-                </a:solidFill>
-              </a:rPr>
-              <a:t>Reasons on every alert (SHAP), a visible trust-in-physics gate, organ-level physiology, AGP report</a:t>
-            </a:r>
-            <a:endParaRPr lang="en-US" sz="1600" dirty="0"/>
-          </a:p>
-        </p:txBody>
-      </p:sp>
-      <p:sp>
-        <p:nvSpPr>
-          <p:cNvPr id="12" name="Shape 10"/>
-          <p:cNvSpPr/>
-          <p:nvPr/>
-        </p:nvSpPr>
-        <p:spPr>
-          <a:xfrm>
-            <a:off x="502920" y="4343400"/>
-            <a:ext cx="457200" cy="457200"/>
-          </a:xfrm>
-          <a:prstGeom prst="ellipse">
-            <a:avLst/>
-          </a:prstGeom>
-          <a:solidFill>
-            <a:srgbClr val="14284B"/>
-          </a:solidFill>
-          <a:ln w="12700">
-            <a:solidFill>
-              <a:srgbClr val="14284B"/>
-            </a:solidFill>
-            <a:prstDash val="solid"/>
-          </a:ln>
-        </p:spPr>
-      </p:sp>
-      <p:sp>
-        <p:nvSpPr>
-          <p:cNvPr id="13" name="Text 11"/>
-          <p:cNvSpPr txBox="1"/>
-          <p:nvPr/>
-        </p:nvSpPr>
-        <p:spPr>
-          <a:xfrm>
-            <a:off x="502920" y="4343400"/>
-            <a:ext cx="457200" cy="457200"/>
-          </a:xfrm>
-          <a:prstGeom prst="rect">
-            <a:avLst/>
-          </a:prstGeom>
-          <a:noFill/>
-          <a:ln/>
-        </p:spPr>
-        <p:txBody>
-          <a:bodyPr wrap="square" lIns="0" tIns="0" rIns="0" bIns="0" rtlCol="0" anchor="ctr"/>
-          <a:lstStyle/>
-          <a:p>
-            <a:pPr algn="ctr" indent="0" marL="0">
-              <a:buNone/>
-            </a:pPr>
-            <a:r>
-              <a:rPr lang="en-US" sz="1400" b="1" dirty="0">
-                <a:solidFill>
-                  <a:srgbClr val="FFFFFF"/>
-                </a:solidFill>
-              </a:rPr>
-              <a:t>4</a:t>
-            </a:r>
-            <a:endParaRPr lang="en-US" sz="1400" dirty="0"/>
-          </a:p>
-        </p:txBody>
-      </p:sp>
-      <p:sp>
-        <p:nvSpPr>
-          <p:cNvPr id="14" name="Text 12"/>
-          <p:cNvSpPr txBox="1"/>
-          <p:nvPr/>
-        </p:nvSpPr>
-        <p:spPr>
-          <a:xfrm>
-            <a:off x="1188720" y="4251960"/>
-            <a:ext cx="10515600" cy="868680"/>
-          </a:xfrm>
-          <a:prstGeom prst="rect">
-            <a:avLst/>
-          </a:prstGeom>
-          <a:noFill/>
-          <a:ln/>
-        </p:spPr>
-        <p:txBody>
-          <a:bodyPr wrap="square" lIns="0" tIns="0" rIns="0" bIns="0" rtlCol="0" anchor="t"/>
-          <a:lstStyle/>
-          <a:p>
-            <a:pPr indent="0" marL="0">
-              <a:buNone/>
-            </a:pPr>
-            <a:r>
-              <a:rPr lang="en-US" sz="1600" b="1" dirty="0">
-                <a:solidFill>
-                  <a:srgbClr val="14284B"/>
-                </a:solidFill>
-              </a:rPr>
-              <a:t>Honest evaluation</a:t>
-            </a:r>
-            <a:endParaRPr lang="en-US" sz="1600" dirty="0"/>
-          </a:p>
-          <a:p>
-            <a:pPr indent="0" marL="0">
-              <a:buNone/>
-            </a:pPr>
-            <a:r>
-              <a:rPr lang="en-US" sz="1400" dirty="0">
-                <a:solidFill>
-                  <a:srgbClr val="4A5260"/>
-                </a:solidFill>
-              </a:rPr>
-              <a:t>Patient-level splits, external validation, bootstrap CIs, model card with limitations</a:t>
-            </a:r>
-            <a:endParaRPr lang="en-US" sz="1600" dirty="0"/>
-          </a:p>
-        </p:txBody>
-      </p:sp>
-      <p:sp>
-        <p:nvSpPr>
-          <p:cNvPr id="15" name="Shape 13"/>
-          <p:cNvSpPr/>
-          <p:nvPr/>
-        </p:nvSpPr>
-        <p:spPr>
-          <a:xfrm>
-            <a:off x="502920" y="5303520"/>
-            <a:ext cx="457200" cy="457200"/>
-          </a:xfrm>
-          <a:prstGeom prst="ellipse">
-            <a:avLst/>
-          </a:prstGeom>
-          <a:solidFill>
-            <a:srgbClr val="14284B"/>
-          </a:solidFill>
-          <a:ln w="12700">
-            <a:solidFill>
-              <a:srgbClr val="14284B"/>
-            </a:solidFill>
-            <a:prstDash val="solid"/>
-          </a:ln>
-        </p:spPr>
-      </p:sp>
-      <p:sp>
-        <p:nvSpPr>
-          <p:cNvPr id="16" name="Text 14"/>
-          <p:cNvSpPr txBox="1"/>
-          <p:nvPr/>
-        </p:nvSpPr>
-        <p:spPr>
-          <a:xfrm>
-            <a:off x="502920" y="5303520"/>
-            <a:ext cx="457200" cy="457200"/>
-          </a:xfrm>
-          <a:prstGeom prst="rect">
-            <a:avLst/>
-          </a:prstGeom>
-          <a:noFill/>
-          <a:ln/>
-        </p:spPr>
-        <p:txBody>
-          <a:bodyPr wrap="square" lIns="0" tIns="0" rIns="0" bIns="0" rtlCol="0" anchor="ctr"/>
-          <a:lstStyle/>
-          <a:p>
-            <a:pPr algn="ctr" indent="0" marL="0">
-              <a:buNone/>
-            </a:pPr>
-            <a:r>
-              <a:rPr lang="en-US" sz="1400" b="1" dirty="0">
-                <a:solidFill>
-                  <a:srgbClr val="FFFFFF"/>
-                </a:solidFill>
-              </a:rPr>
-              <a:t>5</a:t>
-            </a:r>
-            <a:endParaRPr lang="en-US" sz="1400" dirty="0"/>
-          </a:p>
-        </p:txBody>
-      </p:sp>
-      <p:sp>
-        <p:nvSpPr>
-          <p:cNvPr id="17" name="Text 15"/>
-          <p:cNvSpPr txBox="1"/>
-          <p:nvPr/>
-        </p:nvSpPr>
-        <p:spPr>
-          <a:xfrm>
-            <a:off x="1188720" y="5212080"/>
-            <a:ext cx="10515600" cy="868680"/>
-          </a:xfrm>
-          <a:prstGeom prst="rect">
-            <a:avLst/>
-          </a:prstGeom>
-          <a:noFill/>
-          <a:ln/>
-        </p:spPr>
-        <p:txBody>
-          <a:bodyPr wrap="square" lIns="0" tIns="0" rIns="0" bIns="0" rtlCol="0" anchor="t"/>
-          <a:lstStyle/>
-          <a:p>
-            <a:pPr indent="0" marL="0">
-              <a:buNone/>
-            </a:pPr>
-            <a:r>
-              <a:rPr lang="en-US" sz="1600" b="1" dirty="0">
-                <a:solidFill>
-                  <a:srgbClr val="14284B"/>
-                </a:solidFill>
-              </a:rPr>
-              <a:t>Regulatory path</a:t>
-            </a:r>
-            <a:endParaRPr lang="en-US" sz="1600" dirty="0"/>
-          </a:p>
-          <a:p>
-            <a:pPr indent="0" marL="0">
-              <a:buNone/>
-            </a:pPr>
-            <a:r>
-              <a:rPr lang="en-US" sz="1400" dirty="0">
-                <a:solidFill>
-                  <a:srgbClr val="4A5260"/>
-                </a:solidFill>
-              </a:rPr>
-              <a:t>Decision support, not autonomous treatment: CDSCO Software as a Medical Device route with prospective validation</a:t>
-            </a:r>
-            <a:endParaRPr lang="en-US" sz="1600" dirty="0"/>
+              <a:t>trust check: the twin's replay of the last 24 h vs CGM (agreement good)</a:t>
+            </a:r>
+            <a:endParaRPr lang="en-US" sz="1300" dirty="0"/>
           </a:p>
         </p:txBody>
       </p:sp>
@@ -11588,7 +11276,7 @@
                 <a:ea typeface="Cambria" pitchFamily="34" charset="-122"/>
                 <a:cs typeface="Cambria" pitchFamily="34" charset="-120"/>
               </a:rPr>
-              <a:t>From proof of concept to Indian clinics</a:t>
+              <a:t>Responsible by design</a:t>
             </a:r>
             <a:endParaRPr lang="en-US" sz="3000" dirty="0"/>
           </a:p>
@@ -11602,8 +11290,8 @@
         </p:nvSpPr>
         <p:spPr>
           <a:xfrm>
-            <a:off x="502920" y="1600200"/>
-            <a:ext cx="365760" cy="365760"/>
+            <a:off x="502920" y="1463040"/>
+            <a:ext cx="457200" cy="457200"/>
           </a:xfrm>
           <a:prstGeom prst="ellipse">
             <a:avLst/>
@@ -11621,26 +11309,39 @@
       </p:sp>
       <p:sp>
         <p:nvSpPr>
-          <p:cNvPr id="4" name="Shape 2"/>
-          <p:cNvSpPr/>
-          <p:nvPr/>
-        </p:nvSpPr>
-        <p:spPr>
-          <a:xfrm>
-            <a:off x="914400" y="1783080"/>
-            <a:ext cx="2331720" cy="0"/>
-          </a:xfrm>
-          <a:prstGeom prst="line">
-            <a:avLst/>
-          </a:prstGeom>
-          <a:noFill/>
-          <a:ln w="25400">
-            <a:solidFill>
-              <a:srgbClr val="C9D1DE"/>
-            </a:solidFill>
-            <a:prstDash val="solid"/>
-          </a:ln>
-        </p:spPr>
+          <p:cNvPr id="4" name="Text 2"/>
+          <p:cNvSpPr txBox="1"/>
+          <p:nvPr/>
+        </p:nvSpPr>
+        <p:spPr>
+          <a:xfrm>
+            <a:off x="502920" y="1463040"/>
+            <a:ext cx="457200" cy="457200"/>
+          </a:xfrm>
+          <a:prstGeom prst="rect">
+            <a:avLst/>
+          </a:prstGeom>
+          <a:noFill/>
+          <a:ln/>
+        </p:spPr>
+        <p:txBody>
+          <a:bodyPr wrap="square" lIns="0" tIns="0" rIns="0" bIns="0" rtlCol="0" anchor="ctr"/>
+          <a:lstStyle/>
+          <a:p>
+            <a:pPr algn="ctr" indent="0" marL="0">
+              <a:buNone/>
+            </a:pPr>
+            <a:r>
+              <a:rPr lang="en-US" sz="1400" b="1" dirty="0">
+                <a:solidFill>
+                  <a:srgbClr val="14284B"/>
+                </a:solidFill>
+              </a:rPr>
+              <a:t>1</a:t>
+            </a:r>
+            <a:endParaRPr lang="en-US" sz="1400" dirty="0"/>
+          </a:p>
+        </p:txBody>
       </p:sp>
       <p:sp>
         <p:nvSpPr>
@@ -11650,8 +11351,8 @@
         </p:nvSpPr>
         <p:spPr>
           <a:xfrm>
-            <a:off x="457200" y="2148840"/>
-            <a:ext cx="2606040" cy="2103120"/>
+            <a:off x="1188720" y="1371600"/>
+            <a:ext cx="10515600" cy="868680"/>
           </a:xfrm>
           <a:prstGeom prst="rect">
             <a:avLst/>
@@ -11664,54 +11365,31 @@
           <a:lstStyle/>
           <a:p>
             <a:pPr indent="0" marL="0">
-              <a:spcAft>
-                <a:spcPts val="400"/>
-              </a:spcAft>
-              <a:buNone/>
-            </a:pPr>
-            <a:r>
-              <a:rPr lang="en-US" sz="1400" b="1" dirty="0">
-                <a:solidFill>
-                  <a:srgbClr val="7A8291"/>
-                </a:solidFill>
-              </a:rPr>
-              <a:t>Now</a:t>
-            </a:r>
-            <a:endParaRPr lang="en-US" sz="1400" dirty="0"/>
+              <a:buNone/>
+            </a:pPr>
+            <a:r>
+              <a:rPr lang="en-US" sz="1600" b="1" dirty="0">
+                <a:solidFill>
+                  <a:srgbClr val="14284B"/>
+                </a:solidFill>
+              </a:rPr>
+              <a:t>DPDP Act 2023</a:t>
+            </a:r>
+            <a:endParaRPr lang="en-US" sz="1600" dirty="0"/>
           </a:p>
           <a:p>
             <a:pPr indent="0" marL="0">
-              <a:spcAft>
-                <a:spcPts val="400"/>
-              </a:spcAft>
-              <a:buNone/>
-            </a:pPr>
-            <a:r>
-              <a:rPr lang="en-US" sz="1800" b="1" dirty="0">
-                <a:solidFill>
-                  <a:srgbClr val="14284B"/>
-                </a:solidFill>
-              </a:rPr>
-              <a:t>Proof of concept</a:t>
-            </a:r>
-            <a:endParaRPr lang="en-US" sz="1400" dirty="0"/>
-          </a:p>
-          <a:p>
-            <a:pPr indent="0" marL="0">
-              <a:spcAft>
-                <a:spcPts val="400"/>
-              </a:spcAft>
-              <a:buNone/>
-            </a:pPr>
-            <a:r>
-              <a:rPr lang="en-US" sz="1300" dirty="0">
+              <a:buNone/>
+            </a:pPr>
+            <a:r>
+              <a:rPr lang="en-US" sz="1400" dirty="0">
                 <a:solidFill>
                   <a:srgbClr val="4A5260"/>
                 </a:solidFill>
               </a:rPr>
-              <a:t>Twin, TwinNet, dashboard, FHIR; validated on synthetic, US and Chinese data</a:t>
-            </a:r>
-            <a:endParaRPr lang="en-US" sz="1400" dirty="0"/>
+              <a:t>Consent artefacts, purpose limitation, data minimisation, purpose-tagged audit trail; synthetic and de-identified data only</a:t>
+            </a:r>
+            <a:endParaRPr lang="en-US" sz="1600" dirty="0"/>
           </a:p>
         </p:txBody>
       </p:sp>
@@ -11723,8 +11401,8 @@
         </p:nvSpPr>
         <p:spPr>
           <a:xfrm>
-            <a:off x="3337560" y="1600200"/>
-            <a:ext cx="365760" cy="365760"/>
+            <a:off x="502920" y="2423160"/>
+            <a:ext cx="457200" cy="457200"/>
           </a:xfrm>
           <a:prstGeom prst="ellipse">
             <a:avLst/>
@@ -11742,26 +11420,39 @@
       </p:sp>
       <p:sp>
         <p:nvSpPr>
-          <p:cNvPr id="7" name="Shape 5"/>
-          <p:cNvSpPr/>
-          <p:nvPr/>
-        </p:nvSpPr>
-        <p:spPr>
-          <a:xfrm>
-            <a:off x="3749040" y="1783080"/>
-            <a:ext cx="2331720" cy="0"/>
-          </a:xfrm>
-          <a:prstGeom prst="line">
-            <a:avLst/>
-          </a:prstGeom>
-          <a:noFill/>
-          <a:ln w="25400">
-            <a:solidFill>
-              <a:srgbClr val="C9D1DE"/>
-            </a:solidFill>
-            <a:prstDash val="solid"/>
-          </a:ln>
-        </p:spPr>
+          <p:cNvPr id="7" name="Text 5"/>
+          <p:cNvSpPr txBox="1"/>
+          <p:nvPr/>
+        </p:nvSpPr>
+        <p:spPr>
+          <a:xfrm>
+            <a:off x="502920" y="2423160"/>
+            <a:ext cx="457200" cy="457200"/>
+          </a:xfrm>
+          <a:prstGeom prst="rect">
+            <a:avLst/>
+          </a:prstGeom>
+          <a:noFill/>
+          <a:ln/>
+        </p:spPr>
+        <p:txBody>
+          <a:bodyPr wrap="square" lIns="0" tIns="0" rIns="0" bIns="0" rtlCol="0" anchor="ctr"/>
+          <a:lstStyle/>
+          <a:p>
+            <a:pPr algn="ctr" indent="0" marL="0">
+              <a:buNone/>
+            </a:pPr>
+            <a:r>
+              <a:rPr lang="en-US" sz="1400" b="1" dirty="0">
+                <a:solidFill>
+                  <a:srgbClr val="FFFFFF"/>
+                </a:solidFill>
+              </a:rPr>
+              <a:t>2</a:t>
+            </a:r>
+            <a:endParaRPr lang="en-US" sz="1400" dirty="0"/>
+          </a:p>
+        </p:txBody>
       </p:sp>
       <p:sp>
         <p:nvSpPr>
@@ -11771,8 +11462,8 @@
         </p:nvSpPr>
         <p:spPr>
           <a:xfrm>
-            <a:off x="3291840" y="2148840"/>
-            <a:ext cx="2606040" cy="2103120"/>
+            <a:off x="1188720" y="2331720"/>
+            <a:ext cx="10515600" cy="868680"/>
           </a:xfrm>
           <a:prstGeom prst="rect">
             <a:avLst/>
@@ -11785,54 +11476,31 @@
           <a:lstStyle/>
           <a:p>
             <a:pPr indent="0" marL="0">
-              <a:spcAft>
-                <a:spcPts val="400"/>
-              </a:spcAft>
-              <a:buNone/>
-            </a:pPr>
-            <a:r>
-              <a:rPr lang="en-US" sz="1400" b="1" dirty="0">
-                <a:solidFill>
-                  <a:srgbClr val="7A8291"/>
-                </a:solidFill>
-              </a:rPr>
-              <a:t>3 months</a:t>
-            </a:r>
-            <a:endParaRPr lang="en-US" sz="1400" dirty="0"/>
+              <a:buNone/>
+            </a:pPr>
+            <a:r>
+              <a:rPr lang="en-US" sz="1600" b="1" dirty="0">
+                <a:solidFill>
+                  <a:srgbClr val="14284B"/>
+                </a:solidFill>
+              </a:rPr>
+              <a:t>ABDM-ready interoperability</a:t>
+            </a:r>
+            <a:endParaRPr lang="en-US" sz="1600" dirty="0"/>
           </a:p>
           <a:p>
             <a:pPr indent="0" marL="0">
-              <a:spcAft>
-                <a:spcPts val="400"/>
-              </a:spcAft>
-              <a:buNone/>
-            </a:pPr>
-            <a:r>
-              <a:rPr lang="en-US" sz="1800" b="1" dirty="0">
-                <a:solidFill>
-                  <a:srgbClr val="14284B"/>
-                </a:solidFill>
-              </a:rPr>
-              <a:t>Co-design</a:t>
-            </a:r>
-            <a:endParaRPr lang="en-US" sz="1400" dirty="0"/>
-          </a:p>
-          <a:p>
-            <a:pPr indent="0" marL="0">
-              <a:spcAft>
-                <a:spcPts val="400"/>
-              </a:spcAft>
-              <a:buNone/>
-            </a:pPr>
-            <a:r>
-              <a:rPr lang="en-US" sz="1300" dirty="0">
+              <a:buNone/>
+            </a:pPr>
+            <a:r>
+              <a:rPr lang="en-US" sz="1400" dirty="0">
                 <a:solidFill>
                   <a:srgbClr val="4A5260"/>
                 </a:solidFill>
               </a:rPr>
-              <a:t>Diabetologist review of alerts and thresholds; native-speaker review of patient text</a:t>
-            </a:r>
-            <a:endParaRPr lang="en-US" sz="1400" dirty="0"/>
+              <a:t>FHIR R4 with SNOMED CT, LOINC, WHO ATC; CGM as SampledData; the forecast exported as a RiskAssessment</a:t>
+            </a:r>
+            <a:endParaRPr lang="en-US" sz="1600" dirty="0"/>
           </a:p>
         </p:txBody>
       </p:sp>
@@ -11844,8 +11512,8 @@
         </p:nvSpPr>
         <p:spPr>
           <a:xfrm>
-            <a:off x="6172200" y="1600200"/>
-            <a:ext cx="365760" cy="365760"/>
+            <a:off x="502920" y="3383280"/>
+            <a:ext cx="457200" cy="457200"/>
           </a:xfrm>
           <a:prstGeom prst="ellipse">
             <a:avLst/>
@@ -11863,26 +11531,39 @@
       </p:sp>
       <p:sp>
         <p:nvSpPr>
-          <p:cNvPr id="10" name="Shape 8"/>
-          <p:cNvSpPr/>
-          <p:nvPr/>
-        </p:nvSpPr>
-        <p:spPr>
-          <a:xfrm>
-            <a:off x="6583680" y="1783080"/>
-            <a:ext cx="2331720" cy="0"/>
-          </a:xfrm>
-          <a:prstGeom prst="line">
-            <a:avLst/>
-          </a:prstGeom>
-          <a:noFill/>
-          <a:ln w="25400">
-            <a:solidFill>
-              <a:srgbClr val="C9D1DE"/>
-            </a:solidFill>
-            <a:prstDash val="solid"/>
-          </a:ln>
-        </p:spPr>
+          <p:cNvPr id="10" name="Text 8"/>
+          <p:cNvSpPr txBox="1"/>
+          <p:nvPr/>
+        </p:nvSpPr>
+        <p:spPr>
+          <a:xfrm>
+            <a:off x="502920" y="3383280"/>
+            <a:ext cx="457200" cy="457200"/>
+          </a:xfrm>
+          <a:prstGeom prst="rect">
+            <a:avLst/>
+          </a:prstGeom>
+          <a:noFill/>
+          <a:ln/>
+        </p:spPr>
+        <p:txBody>
+          <a:bodyPr wrap="square" lIns="0" tIns="0" rIns="0" bIns="0" rtlCol="0" anchor="ctr"/>
+          <a:lstStyle/>
+          <a:p>
+            <a:pPr algn="ctr" indent="0" marL="0">
+              <a:buNone/>
+            </a:pPr>
+            <a:r>
+              <a:rPr lang="en-US" sz="1400" b="1" dirty="0">
+                <a:solidFill>
+                  <a:srgbClr val="FFFFFF"/>
+                </a:solidFill>
+              </a:rPr>
+              <a:t>3</a:t>
+            </a:r>
+            <a:endParaRPr lang="en-US" sz="1400" dirty="0"/>
+          </a:p>
+        </p:txBody>
       </p:sp>
       <p:sp>
         <p:nvSpPr>
@@ -11892,8 +11573,8 @@
         </p:nvSpPr>
         <p:spPr>
           <a:xfrm>
-            <a:off x="6126480" y="2148840"/>
-            <a:ext cx="2606040" cy="2103120"/>
+            <a:off x="1188720" y="3291840"/>
+            <a:ext cx="10515600" cy="868680"/>
           </a:xfrm>
           <a:prstGeom prst="rect">
             <a:avLst/>
@@ -11906,54 +11587,31 @@
           <a:lstStyle/>
           <a:p>
             <a:pPr indent="0" marL="0">
-              <a:spcAft>
-                <a:spcPts val="400"/>
-              </a:spcAft>
-              <a:buNone/>
-            </a:pPr>
-            <a:r>
-              <a:rPr lang="en-US" sz="1400" b="1" dirty="0">
-                <a:solidFill>
-                  <a:srgbClr val="7A8291"/>
-                </a:solidFill>
-              </a:rPr>
-              <a:t>6 months</a:t>
-            </a:r>
-            <a:endParaRPr lang="en-US" sz="1400" dirty="0"/>
+              <a:buNone/>
+            </a:pPr>
+            <a:r>
+              <a:rPr lang="en-US" sz="1600" b="1" dirty="0">
+                <a:solidFill>
+                  <a:srgbClr val="14284B"/>
+                </a:solidFill>
+              </a:rPr>
+              <a:t>Explainable</a:t>
+            </a:r>
+            <a:endParaRPr lang="en-US" sz="1600" dirty="0"/>
           </a:p>
           <a:p>
             <a:pPr indent="0" marL="0">
-              <a:spcAft>
-                <a:spcPts val="400"/>
-              </a:spcAft>
-              <a:buNone/>
-            </a:pPr>
-            <a:r>
-              <a:rPr lang="en-US" sz="1800" b="1" dirty="0">
-                <a:solidFill>
-                  <a:srgbClr val="14284B"/>
-                </a:solidFill>
-              </a:rPr>
-              <a:t>Pilot</a:t>
-            </a:r>
-            <a:endParaRPr lang="en-US" sz="1400" dirty="0"/>
-          </a:p>
-          <a:p>
-            <a:pPr indent="0" marL="0">
-              <a:spcAft>
-                <a:spcPts val="400"/>
-              </a:spcAft>
-              <a:buNone/>
-            </a:pPr>
-            <a:r>
-              <a:rPr lang="en-US" sz="1300" dirty="0">
+              <a:buNone/>
+            </a:pPr>
+            <a:r>
+              <a:rPr lang="en-US" sz="1400" dirty="0">
                 <a:solidFill>
                   <a:srgbClr val="4A5260"/>
                 </a:solidFill>
               </a:rPr>
-              <a:t>50–100 people with T2D in Bengaluru clinics: CGM + smartwatch + ABDM-linked EHR</a:t>
-            </a:r>
-            <a:endParaRPr lang="en-US" sz="1400" dirty="0"/>
+              <a:t>Reasons on every alert (SHAP), a visible trust-in-physics gate, organ-level physiology, AGP report</a:t>
+            </a:r>
+            <a:endParaRPr lang="en-US" sz="1600" dirty="0"/>
           </a:p>
         </p:txBody>
       </p:sp>
@@ -11965,8 +11623,8 @@
         </p:nvSpPr>
         <p:spPr>
           <a:xfrm>
-            <a:off x="9006840" y="1600200"/>
-            <a:ext cx="365760" cy="365760"/>
+            <a:off x="502920" y="4343400"/>
+            <a:ext cx="457200" cy="457200"/>
           </a:xfrm>
           <a:prstGeom prst="ellipse">
             <a:avLst/>
@@ -11990,8 +11648,8 @@
         </p:nvSpPr>
         <p:spPr>
           <a:xfrm>
-            <a:off x="8961120" y="2148840"/>
-            <a:ext cx="2606040" cy="2103120"/>
+            <a:off x="502920" y="4343400"/>
+            <a:ext cx="457200" cy="457200"/>
           </a:xfrm>
           <a:prstGeom prst="rect">
             <a:avLst/>
@@ -12000,83 +11658,94 @@
           <a:ln/>
         </p:spPr>
         <p:txBody>
+          <a:bodyPr wrap="square" lIns="0" tIns="0" rIns="0" bIns="0" rtlCol="0" anchor="ctr"/>
+          <a:lstStyle/>
+          <a:p>
+            <a:pPr algn="ctr" indent="0" marL="0">
+              <a:buNone/>
+            </a:pPr>
+            <a:r>
+              <a:rPr lang="en-US" sz="1400" b="1" dirty="0">
+                <a:solidFill>
+                  <a:srgbClr val="FFFFFF"/>
+                </a:solidFill>
+              </a:rPr>
+              <a:t>4</a:t>
+            </a:r>
+            <a:endParaRPr lang="en-US" sz="1400" dirty="0"/>
+          </a:p>
+        </p:txBody>
+      </p:sp>
+      <p:sp>
+        <p:nvSpPr>
+          <p:cNvPr id="14" name="Text 12"/>
+          <p:cNvSpPr txBox="1"/>
+          <p:nvPr/>
+        </p:nvSpPr>
+        <p:spPr>
+          <a:xfrm>
+            <a:off x="1188720" y="4251960"/>
+            <a:ext cx="10515600" cy="868680"/>
+          </a:xfrm>
+          <a:prstGeom prst="rect">
+            <a:avLst/>
+          </a:prstGeom>
+          <a:noFill/>
+          <a:ln/>
+        </p:spPr>
+        <p:txBody>
           <a:bodyPr wrap="square" lIns="0" tIns="0" rIns="0" bIns="0" rtlCol="0" anchor="t"/>
           <a:lstStyle/>
           <a:p>
             <a:pPr indent="0" marL="0">
-              <a:spcAft>
-                <a:spcPts val="400"/>
-              </a:spcAft>
-              <a:buNone/>
-            </a:pPr>
-            <a:r>
-              <a:rPr lang="en-US" sz="1400" b="1" dirty="0">
-                <a:solidFill>
-                  <a:srgbClr val="7A8291"/>
-                </a:solidFill>
-              </a:rPr>
-              <a:t>12 months</a:t>
-            </a:r>
-            <a:endParaRPr lang="en-US" sz="1400" dirty="0"/>
+              <a:buNone/>
+            </a:pPr>
+            <a:r>
+              <a:rPr lang="en-US" sz="1600" b="1" dirty="0">
+                <a:solidFill>
+                  <a:srgbClr val="14284B"/>
+                </a:solidFill>
+              </a:rPr>
+              <a:t>Honest evaluation</a:t>
+            </a:r>
+            <a:endParaRPr lang="en-US" sz="1600" dirty="0"/>
           </a:p>
           <a:p>
             <a:pPr indent="0" marL="0">
-              <a:spcAft>
-                <a:spcPts val="400"/>
-              </a:spcAft>
-              <a:buNone/>
-            </a:pPr>
-            <a:r>
-              <a:rPr lang="en-US" sz="1800" b="1" dirty="0">
-                <a:solidFill>
-                  <a:srgbClr val="14284B"/>
-                </a:solidFill>
-              </a:rPr>
-              <a:t>Validation</a:t>
-            </a:r>
-            <a:endParaRPr lang="en-US" sz="1400" dirty="0"/>
-          </a:p>
-          <a:p>
-            <a:pPr indent="0" marL="0">
-              <a:spcAft>
-                <a:spcPts val="400"/>
-              </a:spcAft>
-              <a:buNone/>
-            </a:pPr>
-            <a:r>
-              <a:rPr lang="en-US" sz="1300" dirty="0">
+              <a:buNone/>
+            </a:pPr>
+            <a:r>
+              <a:rPr lang="en-US" sz="1400" dirty="0">
                 <a:solidFill>
                   <a:srgbClr val="4A5260"/>
                 </a:solidFill>
               </a:rPr>
-              <a:t>Prospective accuracy and outcome study; CDSCO SaMD submission</a:t>
-            </a:r>
-            <a:endParaRPr lang="en-US" sz="1400" dirty="0"/>
-          </a:p>
-        </p:txBody>
-      </p:sp>
-      <p:sp>
-        <p:nvSpPr>
-          <p:cNvPr id="14" name="Shape 12"/>
+              <a:t>Patient-level splits, external validation, bootstrap CIs, model card with limitations</a:t>
+            </a:r>
+            <a:endParaRPr lang="en-US" sz="1600" dirty="0"/>
+          </a:p>
+        </p:txBody>
+      </p:sp>
+      <p:sp>
+        <p:nvSpPr>
+          <p:cNvPr id="15" name="Shape 13"/>
           <p:cNvSpPr/>
           <p:nvPr/>
         </p:nvSpPr>
         <p:spPr>
           <a:xfrm>
-            <a:off x="457200" y="4572000"/>
-            <a:ext cx="11247120" cy="1371600"/>
-          </a:xfrm>
-          <a:prstGeom prst="roundRect">
-            <a:avLst>
-              <a:gd name="adj" fmla="val 5333"/>
-            </a:avLst>
+            <a:off x="502920" y="5303520"/>
+            <a:ext cx="457200" cy="457200"/>
+          </a:xfrm>
+          <a:prstGeom prst="ellipse">
+            <a:avLst/>
           </a:prstGeom>
           <a:solidFill>
-            <a:srgbClr val="F2F5FA"/>
+            <a:srgbClr val="14284B"/>
           </a:solidFill>
           <a:ln w="12700">
             <a:solidFill>
-              <a:srgbClr val="F2F5FA"/>
+              <a:srgbClr val="14284B"/>
             </a:solidFill>
             <a:prstDash val="solid"/>
           </a:ln>
@@ -12084,14 +11753,14 @@
       </p:sp>
       <p:sp>
         <p:nvSpPr>
-          <p:cNvPr id="15" name="Text 13"/>
+          <p:cNvPr id="16" name="Text 14"/>
           <p:cNvSpPr txBox="1"/>
           <p:nvPr/>
         </p:nvSpPr>
         <p:spPr>
           <a:xfrm>
-            <a:off x="621792" y="4681728"/>
-            <a:ext cx="10917936" cy="1152144"/>
+            <a:off x="502920" y="5303520"/>
+            <a:ext cx="457200" cy="457200"/>
           </a:xfrm>
           <a:prstGeom prst="rect">
             <a:avLst/>
@@ -12100,41 +11769,71 @@
           <a:ln/>
         </p:spPr>
         <p:txBody>
+          <a:bodyPr wrap="square" lIns="0" tIns="0" rIns="0" bIns="0" rtlCol="0" anchor="ctr"/>
+          <a:lstStyle/>
+          <a:p>
+            <a:pPr algn="ctr" indent="0" marL="0">
+              <a:buNone/>
+            </a:pPr>
+            <a:r>
+              <a:rPr lang="en-US" sz="1400" b="1" dirty="0">
+                <a:solidFill>
+                  <a:srgbClr val="FFFFFF"/>
+                </a:solidFill>
+              </a:rPr>
+              <a:t>5</a:t>
+            </a:r>
+            <a:endParaRPr lang="en-US" sz="1400" dirty="0"/>
+          </a:p>
+        </p:txBody>
+      </p:sp>
+      <p:sp>
+        <p:nvSpPr>
+          <p:cNvPr id="17" name="Text 15"/>
+          <p:cNvSpPr txBox="1"/>
+          <p:nvPr/>
+        </p:nvSpPr>
+        <p:spPr>
+          <a:xfrm>
+            <a:off x="1188720" y="5212080"/>
+            <a:ext cx="10515600" cy="868680"/>
+          </a:xfrm>
+          <a:prstGeom prst="rect">
+            <a:avLst/>
+          </a:prstGeom>
+          <a:noFill/>
+          <a:ln/>
+        </p:spPr>
+        <p:txBody>
           <a:bodyPr wrap="square" lIns="0" tIns="0" rIns="0" bIns="0" rtlCol="0" anchor="t"/>
           <a:lstStyle/>
           <a:p>
             <a:pPr indent="0" marL="0">
-              <a:spcAft>
-                <a:spcPts val="400"/>
-              </a:spcAft>
-              <a:buNone/>
-            </a:pPr>
-            <a:r>
-              <a:rPr lang="en-US" sz="1500" b="1" dirty="0">
+              <a:buNone/>
+            </a:pPr>
+            <a:r>
+              <a:rPr lang="en-US" sz="1600" b="1" dirty="0">
                 <a:solidFill>
                   <a:srgbClr val="14284B"/>
                 </a:solidFill>
               </a:rPr>
-              <a:t>Impact we are aiming for</a:t>
-            </a:r>
-            <a:endParaRPr lang="en-US" sz="1500" dirty="0"/>
+              <a:t>Regulatory path</a:t>
+            </a:r>
+            <a:endParaRPr lang="en-US" sz="1600" dirty="0"/>
           </a:p>
           <a:p>
             <a:pPr indent="0" marL="0">
-              <a:spcAft>
-                <a:spcPts val="400"/>
-              </a:spcAft>
-              <a:buNone/>
-            </a:pPr>
-            <a:r>
-              <a:rPr lang="en-US" sz="1300" dirty="0">
+              <a:buNone/>
+            </a:pPr>
+            <a:r>
+              <a:rPr lang="en-US" sz="1400" dirty="0">
                 <a:solidFill>
                   <a:srgbClr val="4A5260"/>
                 </a:solidFill>
               </a:rPr>
-              <a:t>Fewer nocturnal hypoglycaemia episodes in people on sulfonylureas and premixed insulin, more time in range through personalised meal and activity advice, and a care team that sees risk before it becomes an emergency.</a:t>
-            </a:r>
-            <a:endParaRPr lang="en-US" sz="1500" dirty="0"/>
+              <a:t>Decision support, not autonomous treatment: CDSCO Software as a Medical Device route with prospective validation</a:t>
+            </a:r>
+            <a:endParaRPr lang="en-US" sz="1600" dirty="0"/>
           </a:p>
         </p:txBody>
       </p:sp>
@@ -12194,6 +11893,661 @@
 <file path=ppt/slides/slide24.xml><?xml version="1.0" encoding="utf-8"?>
 <p:sld xmlns:a="http://schemas.openxmlformats.org/drawingml/2006/main" xmlns:r="http://schemas.openxmlformats.org/officeDocument/2006/relationships" xmlns:p="http://schemas.openxmlformats.org/presentationml/2006/main">
   <p:cSld name="Slide 24">
+    <p:spTree>
+      <p:nvGrpSpPr>
+        <p:cNvPr id="1" name=""/>
+        <p:cNvGrpSpPr/>
+        <p:nvPr/>
+      </p:nvGrpSpPr>
+      <p:grpSpPr>
+        <a:xfrm>
+          <a:off x="0" y="0"/>
+          <a:ext cx="0" cy="0"/>
+          <a:chOff x="0" y="0"/>
+          <a:chExt cx="0" cy="0"/>
+        </a:xfrm>
+      </p:grpSpPr>
+      <p:sp>
+        <p:nvSpPr>
+          <p:cNvPr id="2" name="Text 0"/>
+          <p:cNvSpPr txBox="1"/>
+          <p:nvPr/>
+        </p:nvSpPr>
+        <p:spPr>
+          <a:xfrm>
+            <a:off x="457200" y="292608"/>
+            <a:ext cx="9692640" cy="685800"/>
+          </a:xfrm>
+          <a:prstGeom prst="rect">
+            <a:avLst/>
+          </a:prstGeom>
+          <a:noFill/>
+          <a:ln/>
+        </p:spPr>
+        <p:txBody>
+          <a:bodyPr wrap="square" lIns="0" tIns="0" rIns="0" bIns="0" rtlCol="0" anchor="t">
+            <a:normAutofit/>
+          </a:bodyPr>
+          <a:lstStyle/>
+          <a:p>
+            <a:pPr indent="0" marL="0">
+              <a:buNone/>
+            </a:pPr>
+            <a:r>
+              <a:rPr lang="en-US" sz="3000" b="1" dirty="0">
+                <a:solidFill>
+                  <a:srgbClr val="14284B"/>
+                </a:solidFill>
+                <a:latin typeface="Cambria" pitchFamily="34" charset="0"/>
+                <a:ea typeface="Cambria" pitchFamily="34" charset="-122"/>
+                <a:cs typeface="Cambria" pitchFamily="34" charset="-120"/>
+              </a:rPr>
+              <a:t>From proof of concept to Indian clinics</a:t>
+            </a:r>
+            <a:endParaRPr lang="en-US" sz="3000" dirty="0"/>
+          </a:p>
+        </p:txBody>
+      </p:sp>
+      <p:sp>
+        <p:nvSpPr>
+          <p:cNvPr id="3" name="Shape 1"/>
+          <p:cNvSpPr/>
+          <p:nvPr/>
+        </p:nvSpPr>
+        <p:spPr>
+          <a:xfrm>
+            <a:off x="502920" y="1600200"/>
+            <a:ext cx="365760" cy="365760"/>
+          </a:xfrm>
+          <a:prstGeom prst="ellipse">
+            <a:avLst/>
+          </a:prstGeom>
+          <a:solidFill>
+            <a:srgbClr val="E8A317"/>
+          </a:solidFill>
+          <a:ln w="12700">
+            <a:solidFill>
+              <a:srgbClr val="E8A317"/>
+            </a:solidFill>
+            <a:prstDash val="solid"/>
+          </a:ln>
+        </p:spPr>
+      </p:sp>
+      <p:sp>
+        <p:nvSpPr>
+          <p:cNvPr id="4" name="Shape 2"/>
+          <p:cNvSpPr/>
+          <p:nvPr/>
+        </p:nvSpPr>
+        <p:spPr>
+          <a:xfrm>
+            <a:off x="914400" y="1783080"/>
+            <a:ext cx="2331720" cy="0"/>
+          </a:xfrm>
+          <a:prstGeom prst="line">
+            <a:avLst/>
+          </a:prstGeom>
+          <a:noFill/>
+          <a:ln w="25400">
+            <a:solidFill>
+              <a:srgbClr val="C9D1DE"/>
+            </a:solidFill>
+            <a:prstDash val="solid"/>
+          </a:ln>
+        </p:spPr>
+      </p:sp>
+      <p:sp>
+        <p:nvSpPr>
+          <p:cNvPr id="5" name="Text 3"/>
+          <p:cNvSpPr txBox="1"/>
+          <p:nvPr/>
+        </p:nvSpPr>
+        <p:spPr>
+          <a:xfrm>
+            <a:off x="457200" y="2148840"/>
+            <a:ext cx="2606040" cy="2103120"/>
+          </a:xfrm>
+          <a:prstGeom prst="rect">
+            <a:avLst/>
+          </a:prstGeom>
+          <a:noFill/>
+          <a:ln/>
+        </p:spPr>
+        <p:txBody>
+          <a:bodyPr wrap="square" lIns="0" tIns="0" rIns="0" bIns="0" rtlCol="0" anchor="t"/>
+          <a:lstStyle/>
+          <a:p>
+            <a:pPr indent="0" marL="0">
+              <a:spcAft>
+                <a:spcPts val="400"/>
+              </a:spcAft>
+              <a:buNone/>
+            </a:pPr>
+            <a:r>
+              <a:rPr lang="en-US" sz="1400" b="1" dirty="0">
+                <a:solidFill>
+                  <a:srgbClr val="7A8291"/>
+                </a:solidFill>
+              </a:rPr>
+              <a:t>Now</a:t>
+            </a:r>
+            <a:endParaRPr lang="en-US" sz="1400" dirty="0"/>
+          </a:p>
+          <a:p>
+            <a:pPr indent="0" marL="0">
+              <a:spcAft>
+                <a:spcPts val="400"/>
+              </a:spcAft>
+              <a:buNone/>
+            </a:pPr>
+            <a:r>
+              <a:rPr lang="en-US" sz="1800" b="1" dirty="0">
+                <a:solidFill>
+                  <a:srgbClr val="14284B"/>
+                </a:solidFill>
+              </a:rPr>
+              <a:t>Proof of concept</a:t>
+            </a:r>
+            <a:endParaRPr lang="en-US" sz="1400" dirty="0"/>
+          </a:p>
+          <a:p>
+            <a:pPr indent="0" marL="0">
+              <a:spcAft>
+                <a:spcPts val="400"/>
+              </a:spcAft>
+              <a:buNone/>
+            </a:pPr>
+            <a:r>
+              <a:rPr lang="en-US" sz="1300" dirty="0">
+                <a:solidFill>
+                  <a:srgbClr val="4A5260"/>
+                </a:solidFill>
+              </a:rPr>
+              <a:t>Twin, TwinNet, dashboard, FHIR; validated on synthetic, US and Chinese data</a:t>
+            </a:r>
+            <a:endParaRPr lang="en-US" sz="1400" dirty="0"/>
+          </a:p>
+        </p:txBody>
+      </p:sp>
+      <p:sp>
+        <p:nvSpPr>
+          <p:cNvPr id="6" name="Shape 4"/>
+          <p:cNvSpPr/>
+          <p:nvPr/>
+        </p:nvSpPr>
+        <p:spPr>
+          <a:xfrm>
+            <a:off x="3337560" y="1600200"/>
+            <a:ext cx="365760" cy="365760"/>
+          </a:xfrm>
+          <a:prstGeom prst="ellipse">
+            <a:avLst/>
+          </a:prstGeom>
+          <a:solidFill>
+            <a:srgbClr val="14284B"/>
+          </a:solidFill>
+          <a:ln w="12700">
+            <a:solidFill>
+              <a:srgbClr val="14284B"/>
+            </a:solidFill>
+            <a:prstDash val="solid"/>
+          </a:ln>
+        </p:spPr>
+      </p:sp>
+      <p:sp>
+        <p:nvSpPr>
+          <p:cNvPr id="7" name="Shape 5"/>
+          <p:cNvSpPr/>
+          <p:nvPr/>
+        </p:nvSpPr>
+        <p:spPr>
+          <a:xfrm>
+            <a:off x="3749040" y="1783080"/>
+            <a:ext cx="2331720" cy="0"/>
+          </a:xfrm>
+          <a:prstGeom prst="line">
+            <a:avLst/>
+          </a:prstGeom>
+          <a:noFill/>
+          <a:ln w="25400">
+            <a:solidFill>
+              <a:srgbClr val="C9D1DE"/>
+            </a:solidFill>
+            <a:prstDash val="solid"/>
+          </a:ln>
+        </p:spPr>
+      </p:sp>
+      <p:sp>
+        <p:nvSpPr>
+          <p:cNvPr id="8" name="Text 6"/>
+          <p:cNvSpPr txBox="1"/>
+          <p:nvPr/>
+        </p:nvSpPr>
+        <p:spPr>
+          <a:xfrm>
+            <a:off x="3291840" y="2148840"/>
+            <a:ext cx="2606040" cy="2103120"/>
+          </a:xfrm>
+          <a:prstGeom prst="rect">
+            <a:avLst/>
+          </a:prstGeom>
+          <a:noFill/>
+          <a:ln/>
+        </p:spPr>
+        <p:txBody>
+          <a:bodyPr wrap="square" lIns="0" tIns="0" rIns="0" bIns="0" rtlCol="0" anchor="t"/>
+          <a:lstStyle/>
+          <a:p>
+            <a:pPr indent="0" marL="0">
+              <a:spcAft>
+                <a:spcPts val="400"/>
+              </a:spcAft>
+              <a:buNone/>
+            </a:pPr>
+            <a:r>
+              <a:rPr lang="en-US" sz="1400" b="1" dirty="0">
+                <a:solidFill>
+                  <a:srgbClr val="7A8291"/>
+                </a:solidFill>
+              </a:rPr>
+              <a:t>3 months</a:t>
+            </a:r>
+            <a:endParaRPr lang="en-US" sz="1400" dirty="0"/>
+          </a:p>
+          <a:p>
+            <a:pPr indent="0" marL="0">
+              <a:spcAft>
+                <a:spcPts val="400"/>
+              </a:spcAft>
+              <a:buNone/>
+            </a:pPr>
+            <a:r>
+              <a:rPr lang="en-US" sz="1800" b="1" dirty="0">
+                <a:solidFill>
+                  <a:srgbClr val="14284B"/>
+                </a:solidFill>
+              </a:rPr>
+              <a:t>Co-design</a:t>
+            </a:r>
+            <a:endParaRPr lang="en-US" sz="1400" dirty="0"/>
+          </a:p>
+          <a:p>
+            <a:pPr indent="0" marL="0">
+              <a:spcAft>
+                <a:spcPts val="400"/>
+              </a:spcAft>
+              <a:buNone/>
+            </a:pPr>
+            <a:r>
+              <a:rPr lang="en-US" sz="1300" dirty="0">
+                <a:solidFill>
+                  <a:srgbClr val="4A5260"/>
+                </a:solidFill>
+              </a:rPr>
+              <a:t>Diabetologist review of alerts and thresholds; native-speaker review of patient text</a:t>
+            </a:r>
+            <a:endParaRPr lang="en-US" sz="1400" dirty="0"/>
+          </a:p>
+        </p:txBody>
+      </p:sp>
+      <p:sp>
+        <p:nvSpPr>
+          <p:cNvPr id="9" name="Shape 7"/>
+          <p:cNvSpPr/>
+          <p:nvPr/>
+        </p:nvSpPr>
+        <p:spPr>
+          <a:xfrm>
+            <a:off x="6172200" y="1600200"/>
+            <a:ext cx="365760" cy="365760"/>
+          </a:xfrm>
+          <a:prstGeom prst="ellipse">
+            <a:avLst/>
+          </a:prstGeom>
+          <a:solidFill>
+            <a:srgbClr val="14284B"/>
+          </a:solidFill>
+          <a:ln w="12700">
+            <a:solidFill>
+              <a:srgbClr val="14284B"/>
+            </a:solidFill>
+            <a:prstDash val="solid"/>
+          </a:ln>
+        </p:spPr>
+      </p:sp>
+      <p:sp>
+        <p:nvSpPr>
+          <p:cNvPr id="10" name="Shape 8"/>
+          <p:cNvSpPr/>
+          <p:nvPr/>
+        </p:nvSpPr>
+        <p:spPr>
+          <a:xfrm>
+            <a:off x="6583680" y="1783080"/>
+            <a:ext cx="2331720" cy="0"/>
+          </a:xfrm>
+          <a:prstGeom prst="line">
+            <a:avLst/>
+          </a:prstGeom>
+          <a:noFill/>
+          <a:ln w="25400">
+            <a:solidFill>
+              <a:srgbClr val="C9D1DE"/>
+            </a:solidFill>
+            <a:prstDash val="solid"/>
+          </a:ln>
+        </p:spPr>
+      </p:sp>
+      <p:sp>
+        <p:nvSpPr>
+          <p:cNvPr id="11" name="Text 9"/>
+          <p:cNvSpPr txBox="1"/>
+          <p:nvPr/>
+        </p:nvSpPr>
+        <p:spPr>
+          <a:xfrm>
+            <a:off x="6126480" y="2148840"/>
+            <a:ext cx="2606040" cy="2103120"/>
+          </a:xfrm>
+          <a:prstGeom prst="rect">
+            <a:avLst/>
+          </a:prstGeom>
+          <a:noFill/>
+          <a:ln/>
+        </p:spPr>
+        <p:txBody>
+          <a:bodyPr wrap="square" lIns="0" tIns="0" rIns="0" bIns="0" rtlCol="0" anchor="t"/>
+          <a:lstStyle/>
+          <a:p>
+            <a:pPr indent="0" marL="0">
+              <a:spcAft>
+                <a:spcPts val="400"/>
+              </a:spcAft>
+              <a:buNone/>
+            </a:pPr>
+            <a:r>
+              <a:rPr lang="en-US" sz="1400" b="1" dirty="0">
+                <a:solidFill>
+                  <a:srgbClr val="7A8291"/>
+                </a:solidFill>
+              </a:rPr>
+              <a:t>6 months</a:t>
+            </a:r>
+            <a:endParaRPr lang="en-US" sz="1400" dirty="0"/>
+          </a:p>
+          <a:p>
+            <a:pPr indent="0" marL="0">
+              <a:spcAft>
+                <a:spcPts val="400"/>
+              </a:spcAft>
+              <a:buNone/>
+            </a:pPr>
+            <a:r>
+              <a:rPr lang="en-US" sz="1800" b="1" dirty="0">
+                <a:solidFill>
+                  <a:srgbClr val="14284B"/>
+                </a:solidFill>
+              </a:rPr>
+              <a:t>Pilot</a:t>
+            </a:r>
+            <a:endParaRPr lang="en-US" sz="1400" dirty="0"/>
+          </a:p>
+          <a:p>
+            <a:pPr indent="0" marL="0">
+              <a:spcAft>
+                <a:spcPts val="400"/>
+              </a:spcAft>
+              <a:buNone/>
+            </a:pPr>
+            <a:r>
+              <a:rPr lang="en-US" sz="1300" dirty="0">
+                <a:solidFill>
+                  <a:srgbClr val="4A5260"/>
+                </a:solidFill>
+              </a:rPr>
+              <a:t>50–100 people with T2D in Bengaluru clinics: CGM + smartwatch + ABDM-linked EHR</a:t>
+            </a:r>
+            <a:endParaRPr lang="en-US" sz="1400" dirty="0"/>
+          </a:p>
+        </p:txBody>
+      </p:sp>
+      <p:sp>
+        <p:nvSpPr>
+          <p:cNvPr id="12" name="Shape 10"/>
+          <p:cNvSpPr/>
+          <p:nvPr/>
+        </p:nvSpPr>
+        <p:spPr>
+          <a:xfrm>
+            <a:off x="9006840" y="1600200"/>
+            <a:ext cx="365760" cy="365760"/>
+          </a:xfrm>
+          <a:prstGeom prst="ellipse">
+            <a:avLst/>
+          </a:prstGeom>
+          <a:solidFill>
+            <a:srgbClr val="14284B"/>
+          </a:solidFill>
+          <a:ln w="12700">
+            <a:solidFill>
+              <a:srgbClr val="14284B"/>
+            </a:solidFill>
+            <a:prstDash val="solid"/>
+          </a:ln>
+        </p:spPr>
+      </p:sp>
+      <p:sp>
+        <p:nvSpPr>
+          <p:cNvPr id="13" name="Text 11"/>
+          <p:cNvSpPr txBox="1"/>
+          <p:nvPr/>
+        </p:nvSpPr>
+        <p:spPr>
+          <a:xfrm>
+            <a:off x="8961120" y="2148840"/>
+            <a:ext cx="2606040" cy="2103120"/>
+          </a:xfrm>
+          <a:prstGeom prst="rect">
+            <a:avLst/>
+          </a:prstGeom>
+          <a:noFill/>
+          <a:ln/>
+        </p:spPr>
+        <p:txBody>
+          <a:bodyPr wrap="square" lIns="0" tIns="0" rIns="0" bIns="0" rtlCol="0" anchor="t"/>
+          <a:lstStyle/>
+          <a:p>
+            <a:pPr indent="0" marL="0">
+              <a:spcAft>
+                <a:spcPts val="400"/>
+              </a:spcAft>
+              <a:buNone/>
+            </a:pPr>
+            <a:r>
+              <a:rPr lang="en-US" sz="1400" b="1" dirty="0">
+                <a:solidFill>
+                  <a:srgbClr val="7A8291"/>
+                </a:solidFill>
+              </a:rPr>
+              <a:t>12 months</a:t>
+            </a:r>
+            <a:endParaRPr lang="en-US" sz="1400" dirty="0"/>
+          </a:p>
+          <a:p>
+            <a:pPr indent="0" marL="0">
+              <a:spcAft>
+                <a:spcPts val="400"/>
+              </a:spcAft>
+              <a:buNone/>
+            </a:pPr>
+            <a:r>
+              <a:rPr lang="en-US" sz="1800" b="1" dirty="0">
+                <a:solidFill>
+                  <a:srgbClr val="14284B"/>
+                </a:solidFill>
+              </a:rPr>
+              <a:t>Validation</a:t>
+            </a:r>
+            <a:endParaRPr lang="en-US" sz="1400" dirty="0"/>
+          </a:p>
+          <a:p>
+            <a:pPr indent="0" marL="0">
+              <a:spcAft>
+                <a:spcPts val="400"/>
+              </a:spcAft>
+              <a:buNone/>
+            </a:pPr>
+            <a:r>
+              <a:rPr lang="en-US" sz="1300" dirty="0">
+                <a:solidFill>
+                  <a:srgbClr val="4A5260"/>
+                </a:solidFill>
+              </a:rPr>
+              <a:t>Prospective accuracy and outcome study; CDSCO SaMD submission</a:t>
+            </a:r>
+            <a:endParaRPr lang="en-US" sz="1400" dirty="0"/>
+          </a:p>
+        </p:txBody>
+      </p:sp>
+      <p:sp>
+        <p:nvSpPr>
+          <p:cNvPr id="14" name="Shape 12"/>
+          <p:cNvSpPr/>
+          <p:nvPr/>
+        </p:nvSpPr>
+        <p:spPr>
+          <a:xfrm>
+            <a:off x="457200" y="4572000"/>
+            <a:ext cx="11247120" cy="1371600"/>
+          </a:xfrm>
+          <a:prstGeom prst="roundRect">
+            <a:avLst>
+              <a:gd name="adj" fmla="val 5333"/>
+            </a:avLst>
+          </a:prstGeom>
+          <a:solidFill>
+            <a:srgbClr val="F2F5FA"/>
+          </a:solidFill>
+          <a:ln w="12700">
+            <a:solidFill>
+              <a:srgbClr val="F2F5FA"/>
+            </a:solidFill>
+            <a:prstDash val="solid"/>
+          </a:ln>
+        </p:spPr>
+      </p:sp>
+      <p:sp>
+        <p:nvSpPr>
+          <p:cNvPr id="15" name="Text 13"/>
+          <p:cNvSpPr txBox="1"/>
+          <p:nvPr/>
+        </p:nvSpPr>
+        <p:spPr>
+          <a:xfrm>
+            <a:off x="621792" y="4681728"/>
+            <a:ext cx="10917936" cy="1152144"/>
+          </a:xfrm>
+          <a:prstGeom prst="rect">
+            <a:avLst/>
+          </a:prstGeom>
+          <a:noFill/>
+          <a:ln/>
+        </p:spPr>
+        <p:txBody>
+          <a:bodyPr wrap="square" lIns="0" tIns="0" rIns="0" bIns="0" rtlCol="0" anchor="t"/>
+          <a:lstStyle/>
+          <a:p>
+            <a:pPr indent="0" marL="0">
+              <a:spcAft>
+                <a:spcPts val="400"/>
+              </a:spcAft>
+              <a:buNone/>
+            </a:pPr>
+            <a:r>
+              <a:rPr lang="en-US" sz="1500" b="1" dirty="0">
+                <a:solidFill>
+                  <a:srgbClr val="14284B"/>
+                </a:solidFill>
+              </a:rPr>
+              <a:t>Impact we are aiming for</a:t>
+            </a:r>
+            <a:endParaRPr lang="en-US" sz="1500" dirty="0"/>
+          </a:p>
+          <a:p>
+            <a:pPr indent="0" marL="0">
+              <a:spcAft>
+                <a:spcPts val="400"/>
+              </a:spcAft>
+              <a:buNone/>
+            </a:pPr>
+            <a:r>
+              <a:rPr lang="en-US" sz="1300" dirty="0">
+                <a:solidFill>
+                  <a:srgbClr val="4A5260"/>
+                </a:solidFill>
+              </a:rPr>
+              <a:t>Fewer nocturnal hypoglycaemia episodes in people on sulfonylureas and premixed insulin, more time in range through personalised meal and activity advice, and a care team that sees risk before it becomes an emergency.</a:t>
+            </a:r>
+            <a:endParaRPr lang="en-US" sz="1500" dirty="0"/>
+          </a:p>
+        </p:txBody>
+      </p:sp>
+      <p:sp>
+        <p:nvSpPr>
+          <p:cNvPr id="25" name="Slide Number Placeholder 0"/>
+          <p:cNvSpPr>
+            <a:spLocks noGrp="1"/>
+          </p:cNvSpPr>
+          <p:nvPr>
+            <p:ph type="sldNum" sz="quarter" idx="4294967295"/>
+          </p:nvPr>
+        </p:nvSpPr>
+        <p:spPr>
+          <a:xfrm>
+            <a:off x="11247120" y="6446520"/>
+            <a:ext cx="548640" cy="274320"/>
+          </a:xfrm>
+          <a:prstGeom prst="rect">
+            <a:avLst/>
+          </a:prstGeom>
+          <a:extLst>
+            <a:ext uri="{C572A759-6A51-4108-AA02-DFA0A04FC94B}">
+              <ma14:wrappingTextBoxFlag xmlns:ma14="http://schemas.microsoft.com/office/mac/drawingml/2011/main" val="0"/>
+            </a:ext>
+          </a:extLst>
+        </p:spPr>
+        <p:txBody>
+          <a:bodyPr/>
+          <a:lstStyle>
+            <a:lvl1pPr>
+              <a:defRPr sz="1000">
+                <a:solidFill>
+                  <a:srgbClr val="7A8291"/>
+                </a:solidFill>
+              </a:defRPr>
+            </a:lvl1pPr>
+          </a:lstStyle>
+          <a:p>
+            <a:pPr algn="r"/>
+            <a:fld id="{F7021451-1387-4CA6-816F-3879F97B5CBC}" type="slidenum">
+              <a:rPr b="0" lang="en-US"/>
+              <a:t>24</a:t>
+            </a:fld>
+            <a:endParaRPr lang="en-US"/>
+          </a:p>
+        </p:txBody>
+      </p:sp>
+    </p:spTree>
+  </p:cSld>
+  <p:clrMapOvr>
+    <a:masterClrMapping/>
+  </p:clrMapOvr>
+</p:sld>
+</file>
+
+<file path=ppt/slides/slide25.xml><?xml version="1.0" encoding="utf-8"?>
+<p:sld xmlns:a="http://schemas.openxmlformats.org/drawingml/2006/main" xmlns:r="http://schemas.openxmlformats.org/officeDocument/2006/relationships" xmlns:p="http://schemas.openxmlformats.org/presentationml/2006/main">
+  <p:cSld name="Slide 25">
     <p:spTree>
       <p:nvGrpSpPr>
         <p:cNvPr id="1" name=""/>

</xml_diff>

<commit_message>
Add team ClockItTwin (IIT Kharagpur) details and roles; fill deck, report and README
Team details in the README, title and closing slides and the technical report;
README links the renamed repository. Personal contact details are kept out of the
public README (they belong in the submission form).

Co-Authored-By: Claude Opus 5.5 <noreply@anthropic.com>
</commit_message>
<xml_diff>
--- a/docs/presentation.pptx
+++ b/docs/presentation.pptx
@@ -131,32 +131,32 @@
   <p:extLst>
     <p:ext uri="{521415D9-36F7-43E2-AB2F-B90AF26B5E84}">
       <p14:sectionLst xmlns:p14="http://schemas.microsoft.com/office/powerpoint/2010/main">
-        <p14:section name="Opening" id="{2e8e468d-06d9-33d7-dca3-a7ed1cac914b}">
+        <p14:section name="Opening" id="{4a0a495a-81d1-90cb-0e51-c52a85f29884}">
           <p14:sldIdLst>
             <p14:sldId id="256"/>
             <p14:sldId id="257"/>
           </p14:sldIdLst>
         </p14:section>
-        <p14:section name="The digital twin" id="{686723de-786e-3d71-e857-bcea11340dcb}">
+        <p14:section name="The digital twin" id="{29af15e7-9e8d-734a-6598-3bf6143ec4f1}">
           <p14:sldIdLst>
             <p14:sldId id="258"/>
             <p14:sldId id="259"/>
           </p14:sldIdLst>
         </p14:section>
-        <p14:section name="Data" id="{4a501251-4526-85db-3933-59d8d6d1671d}">
+        <p14:section name="Data" id="{ace94256-5969-ea5f-d62e-fb4c882592eb}">
           <p14:sldIdLst>
             <p14:sldId id="260"/>
             <p14:sldId id="261"/>
           </p14:sldIdLst>
         </p14:section>
-        <p14:section name="Model · Sync · Simulate" id="{a8815f1c-17bf-722e-4e17-0067cbd7e97f}">
+        <p14:section name="Model · Sync · Simulate" id="{40b1eaea-34ab-0e65-7d82-cd57d8d271e8}">
           <p14:sldIdLst>
             <p14:sldId id="262"/>
             <p14:sldId id="263"/>
             <p14:sldId id="264"/>
           </p14:sldIdLst>
         </p14:section>
-        <p14:section name="Results" id="{6fa930e6-0da7-2f47-4d23-861957247f91}">
+        <p14:section name="Results" id="{f7362495-efb5-7726-123e-9c7bac595c11}">
           <p14:sldIdLst>
             <p14:sldId id="265"/>
             <p14:sldId id="266"/>
@@ -168,7 +168,7 @@
             <p14:sldId id="272"/>
           </p14:sldIdLst>
         </p14:section>
-        <p14:section name="Dashboard" id="{c23e3608-f6fb-868c-2acb-5a4c06e4caed}">
+        <p14:section name="Dashboard" id="{59c093e3-2455-4f95-e267-4cdb1fe46efc}">
           <p14:sldIdLst>
             <p14:sldId id="273"/>
             <p14:sldId id="274"/>
@@ -177,7 +177,7 @@
             <p14:sldId id="277"/>
           </p14:sldIdLst>
         </p14:section>
-        <p14:section name="Responsible by design" id="{1c197fd3-c935-0df9-df03-0c2a17a6a9e0}">
+        <p14:section name="Responsible by design" id="{965d6a47-4c31-1f9e-e86d-1b8f93213a34}">
           <p14:sldIdLst>
             <p14:sldId id="278"/>
             <p14:sldId id="279"/>
@@ -3555,7 +3555,7 @@
                   <a:srgbClr val="FFFFFF"/>
                 </a:solidFill>
               </a:rPr>
-              <a:t>Team: TODO(team) · College / incubator: TODO(team)</a:t>
+              <a:t>Team ClockItTwin · IIT Kharagpur</a:t>
             </a:r>
             <a:endParaRPr lang="en-US" sz="1600" dirty="0"/>
           </a:p>
@@ -12667,7 +12667,7 @@
                   <a:srgbClr val="FFFFFF"/>
                 </a:solidFill>
               </a:rPr>
-              <a:t>Code, data pipeline, evaluation and dashboard: GitHub repository TODO(team) · Apache-2.0</a:t>
+              <a:t>Code, data pipeline, evaluation and dashboard: github.com/ShubAce/MadhuTwin · Apache-2.0</a:t>
             </a:r>
             <a:endParaRPr lang="en-US" sz="1600" dirty="0"/>
           </a:p>
@@ -12703,7 +12703,7 @@
                   <a:srgbClr val="AEBBD3"/>
                 </a:solidFill>
               </a:rPr>
-              <a:t>Team: TODO(team)</a:t>
+              <a:t>Team ClockItTwin · IIT Kharagpur: Shubham Suman, Krupal Thakre, Durgesh Kumar, Anurag Ranjan</a:t>
             </a:r>
             <a:endParaRPr lang="en-US" sz="1600" dirty="0"/>
           </a:p>

</xml_diff>

<commit_message>
Add live demo link (madhutwin.onrender.com) to README and closing slide
Co-Authored-By: Claude Opus 5.5 <noreply@anthropic.com>
</commit_message>
<xml_diff>
--- a/docs/presentation.pptx
+++ b/docs/presentation.pptx
@@ -131,32 +131,32 @@
   <p:extLst>
     <p:ext uri="{521415D9-36F7-43E2-AB2F-B90AF26B5E84}">
       <p14:sectionLst xmlns:p14="http://schemas.microsoft.com/office/powerpoint/2010/main">
-        <p14:section name="Opening" id="{4a0a495a-81d1-90cb-0e51-c52a85f29884}">
+        <p14:section name="Opening" id="{ba4453f3-12c2-1723-918c-df6b675fa4a6}">
           <p14:sldIdLst>
             <p14:sldId id="256"/>
             <p14:sldId id="257"/>
           </p14:sldIdLst>
         </p14:section>
-        <p14:section name="The digital twin" id="{29af15e7-9e8d-734a-6598-3bf6143ec4f1}">
+        <p14:section name="The digital twin" id="{dc9a62a8-c1ec-9af7-fa4f-6a87684650b6}">
           <p14:sldIdLst>
             <p14:sldId id="258"/>
             <p14:sldId id="259"/>
           </p14:sldIdLst>
         </p14:section>
-        <p14:section name="Data" id="{ace94256-5969-ea5f-d62e-fb4c882592eb}">
+        <p14:section name="Data" id="{43a957d9-50f7-5c84-3f56-db10d43d23a9}">
           <p14:sldIdLst>
             <p14:sldId id="260"/>
             <p14:sldId id="261"/>
           </p14:sldIdLst>
         </p14:section>
-        <p14:section name="Model · Sync · Simulate" id="{40b1eaea-34ab-0e65-7d82-cd57d8d271e8}">
+        <p14:section name="Model · Sync · Simulate" id="{161e3652-ddd1-31a9-cb9a-42599ef456f2}">
           <p14:sldIdLst>
             <p14:sldId id="262"/>
             <p14:sldId id="263"/>
             <p14:sldId id="264"/>
           </p14:sldIdLst>
         </p14:section>
-        <p14:section name="Results" id="{f7362495-efb5-7726-123e-9c7bac595c11}">
+        <p14:section name="Results" id="{277e1380-a3c8-9e2c-e3bf-77255d5aa268}">
           <p14:sldIdLst>
             <p14:sldId id="265"/>
             <p14:sldId id="266"/>
@@ -168,7 +168,7 @@
             <p14:sldId id="272"/>
           </p14:sldIdLst>
         </p14:section>
-        <p14:section name="Dashboard" id="{59c093e3-2455-4f95-e267-4cdb1fe46efc}">
+        <p14:section name="Dashboard" id="{fb8e106d-7db1-33ed-9154-0cd9b2a8d107}">
           <p14:sldIdLst>
             <p14:sldId id="273"/>
             <p14:sldId id="274"/>
@@ -177,7 +177,7 @@
             <p14:sldId id="277"/>
           </p14:sldIdLst>
         </p14:section>
-        <p14:section name="Responsible by design" id="{965d6a47-4c31-1f9e-e86d-1b8f93213a34}">
+        <p14:section name="Responsible by design" id="{5c5ebe42-b895-5387-7e57-7e6db137d487}">
           <p14:sldIdLst>
             <p14:sldId id="278"/>
             <p14:sldId id="279"/>
@@ -12667,7 +12667,7 @@
                   <a:srgbClr val="FFFFFF"/>
                 </a:solidFill>
               </a:rPr>
-              <a:t>Code, data pipeline, evaluation and dashboard: github.com/ShubAce/MadhuTwin · Apache-2.0</a:t>
+              <a:t>Live demo: madhutwin.onrender.com · Code: github.com/ShubAce/MadhuTwin · Apache-2.0</a:t>
             </a:r>
             <a:endParaRPr lang="en-US" sz="1600" dirty="0"/>
           </a:p>

</xml_diff>